<commit_message>
Deck: add Jim Simons portrait on slide 4 (photo supplied by channel owner)
Co-Authored-By: Claude Opus 5.5 <noreply@anthropic.com>
Claude-Session: https://claude.ai/code/session_01KWqQzsgRC2BQLPS1tn2f7H
</commit_message>
<xml_diff>
--- a/video/jim-simons-documentary/deck/The-Mathematicians-Edge-Hinglish.pptx
+++ b/video/jim-simons-documentary/deck/The-Mathematicians-Edge-Hinglish.pptx
@@ -1967,7 +1967,7 @@
           <a:p>
             <a:r>
               <a:rPr lang="en-US" dirty="0"/>
-              <a:t>Is slide par Jim Simons ki licensed photo lagayein (photo slot).
+              <a:t>Photo credit line (slide par "Photo: [source / credit]") mein photo ka source likh dein.
 [Video 00:55 · Scene S05]
 1982 mein, Jim Simons ne Renaissance Technologies ki foundation rakhi. Simons ek mathematician aur former signals analyst the — aur market ko dekhne ka unka nazariya traditional traders se bilkul alag tha.</a:t>
             </a:r>
@@ -10408,35 +10408,64 @@
         </p:nvSpPr>
         <p:spPr>
           <a:xfrm>
-            <a:off x="5120640" y="1234440"/>
-            <a:ext cx="3566160" cy="3291840"/>
-          </a:xfrm>
-          <a:prstGeom prst="roundRect">
-            <a:avLst>
-              <a:gd name="adj" fmla="val 3333"/>
-            </a:avLst>
+            <a:off x="5413248" y="1207008"/>
+            <a:ext cx="3072384" cy="3072384"/>
+          </a:xfrm>
+          <a:prstGeom prst="rect">
+            <a:avLst/>
           </a:prstGeom>
           <a:solidFill>
-            <a:srgbClr val="141C26"/>
+            <a:srgbClr val="2A3542"/>
           </a:solidFill>
           <a:ln w="12700">
             <a:solidFill>
-              <a:srgbClr val="8A97A4"/>
+              <a:srgbClr val="2A3542"/>
             </a:solidFill>
-            <a:prstDash val="dash"/>
+            <a:prstDash val="solid"/>
           </a:ln>
-        </p:spPr>
-      </p:sp>
-      <p:sp>
-        <p:nvSpPr>
-          <p:cNvPr id="8" name="Text 6"/>
-          <p:cNvSpPr txBox="1"/>
-          <p:nvPr/>
-        </p:nvSpPr>
-        <p:spPr>
-          <a:xfrm>
-            <a:off x="5349240" y="2011680"/>
-            <a:ext cx="3108960" cy="1737360"/>
+          <a:effectLst>
+            <a:outerShdw sx="100000" sy="100000" kx="0" ky="0" algn="bl" rotWithShape="0" blurRad="152400" dist="38100" dir="5400000">
+              <a:srgbClr val="000000">
+                <a:alpha val="45000"/>
+              </a:srgbClr>
+            </a:outerShdw>
+          </a:effectLst>
+        </p:spPr>
+      </p:sp>
+      <p:pic>
+        <p:nvPicPr>
+          <p:cNvPr id="8" name="Image 0" descr="Portrait of Jim Simons">    </p:cNvPr>
+          <p:cNvPicPr>
+            <a:picLocks noChangeAspect="1"/>
+          </p:cNvPicPr>
+          <p:nvPr/>
+        </p:nvPicPr>
+        <p:blipFill>
+          <a:blip r:embed="rId1"/>
+          <a:stretch>
+            <a:fillRect/>
+          </a:stretch>
+        </p:blipFill>
+        <p:spPr>
+          <a:xfrm>
+            <a:off x="5440680" y="1234440"/>
+            <a:ext cx="3017520" cy="3017520"/>
+          </a:xfrm>
+          <a:prstGeom prst="rect">
+            <a:avLst/>
+          </a:prstGeom>
+        </p:spPr>
+      </p:pic>
+      <p:sp>
+        <p:nvSpPr>
+          <p:cNvPr id="9" name="Text 6"/>
+          <p:cNvSpPr txBox="1"/>
+          <p:nvPr/>
+        </p:nvSpPr>
+        <p:spPr>
+          <a:xfrm>
+            <a:off x="5440680" y="4361688"/>
+            <a:ext cx="3017520" cy="274320"/>
           </a:xfrm>
           <a:prstGeom prst="rect">
             <a:avLst/>
@@ -10448,45 +10477,50 @@
           <a:bodyPr wrap="square" lIns="0" tIns="0" rIns="0" bIns="0" rtlCol="0" anchor="ctr"/>
           <a:lstStyle/>
           <a:p>
-            <a:pPr algn="ctr" indent="0" marL="0">
-              <a:buNone/>
-            </a:pPr>
-            <a:r>
-              <a:rPr lang="en-US" sz="1200" b="1" spc="300" kern="0" dirty="0">
-                <a:solidFill>
-                  <a:srgbClr val="F0C75E"/>
-                </a:solidFill>
-                <a:latin typeface="Calibri" pitchFamily="34" charset="0"/>
-                <a:ea typeface="Calibri" pitchFamily="34" charset="-122"/>
-                <a:cs typeface="Calibri" pitchFamily="34" charset="-120"/>
-              </a:rPr>
-              <a:t>PHOTO SLOT</a:t>
-            </a:r>
-            <a:endParaRPr lang="en-US" sz="1200" dirty="0"/>
-          </a:p>
-          <a:p>
-            <a:pPr algn="ctr" indent="0" marL="0">
-              <a:buNone/>
-            </a:pPr>
-            <a:r>
-              <a:rPr lang="en-US" sz="1300" dirty="0">
+            <a:pPr indent="0" marL="0">
+              <a:buNone/>
+            </a:pPr>
+            <a:r>
+              <a:rPr lang="en-US" sz="1400" dirty="0">
                 <a:solidFill>
                   <a:srgbClr val="DBE3EA"/>
                 </a:solidFill>
-                <a:latin typeface="Calibri" pitchFamily="34" charset="0"/>
-                <a:ea typeface="Calibri" pitchFamily="34" charset="-122"/>
-                <a:cs typeface="Calibri" pitchFamily="34" charset="-120"/>
-              </a:rPr>
-              <a:t>Jim Simons ki real photo yahan lagayein</a:t>
-            </a:r>
-            <a:endParaRPr lang="en-US" sz="1200" dirty="0"/>
-          </a:p>
-          <a:p>
-            <a:pPr algn="ctr" indent="0" marL="0">
-              <a:buNone/>
-            </a:pPr>
-            <a:r>
-              <a:rPr lang="en-US" sz="1000" dirty="0">
+                <a:latin typeface="Cambria" pitchFamily="34" charset="0"/>
+                <a:ea typeface="Cambria" pitchFamily="34" charset="-122"/>
+                <a:cs typeface="Cambria" pitchFamily="34" charset="-120"/>
+              </a:rPr>
+              <a:t>Jim Simons</a:t>
+            </a:r>
+            <a:endParaRPr lang="en-US" sz="1400" dirty="0"/>
+          </a:p>
+        </p:txBody>
+      </p:sp>
+      <p:sp>
+        <p:nvSpPr>
+          <p:cNvPr id="10" name="Text 7"/>
+          <p:cNvSpPr txBox="1"/>
+          <p:nvPr/>
+        </p:nvSpPr>
+        <p:spPr>
+          <a:xfrm>
+            <a:off x="5440680" y="4636008"/>
+            <a:ext cx="3017520" cy="201168"/>
+          </a:xfrm>
+          <a:prstGeom prst="rect">
+            <a:avLst/>
+          </a:prstGeom>
+          <a:noFill/>
+          <a:ln/>
+        </p:spPr>
+        <p:txBody>
+          <a:bodyPr wrap="square" lIns="0" tIns="0" rIns="0" bIns="0" rtlCol="0" anchor="ctr"/>
+          <a:lstStyle/>
+          <a:p>
+            <a:pPr indent="0" marL="0">
+              <a:buNone/>
+            </a:pPr>
+            <a:r>
+              <a:rPr lang="en-US" sz="800" dirty="0">
                 <a:solidFill>
                   <a:srgbClr val="8A97A4"/>
                 </a:solidFill>
@@ -10494,9 +10528,9 @@
                 <a:ea typeface="Calibri" pitchFamily="34" charset="-122"/>
                 <a:cs typeface="Calibri" pitchFamily="34" charset="-120"/>
               </a:rPr>
-              <a:t>Licensed image hi use karein (Getty / AP) ya Wikimedia Commons ki CC photo — attribution ke saath. Is box ko delete karke photo drag-and-drop karein.</a:t>
-            </a:r>
-            <a:endParaRPr lang="en-US" sz="1200" dirty="0"/>
+              <a:t>Photo: [source / credit]</a:t>
+            </a:r>
+            <a:endParaRPr lang="en-US" sz="800" dirty="0"/>
           </a:p>
         </p:txBody>
       </p:sp>

</xml_diff>

<commit_message>
Deck: fix text overlaps for any font fallback
Heading+body pairs share one text box so wrapping flows down instead of
colliding; one-line 24pt titles; captions sit clear of image shadows.
Adds a wide-fallback-font QA build (DECK_WIDE_FONTS=1) and qa/check.sh;
both font modes report 0 overlaps.

Co-Authored-By: Claude Opus 5.5 <noreply@anthropic.com>
Claude-Session: https://claude.ai/code/session_01KWqQzsgRC2BQLPS1tn2f7H
</commit_message>
<xml_diff>
--- a/video/jim-simons-documentary/deck/The-Mathematicians-Edge-Hinglish.pptx
+++ b/video/jim-simons-documentary/deck/The-Mathematicians-Edge-Hinglish.pptx
@@ -2809,7 +2809,7 @@
         </p:blipFill>
         <p:spPr>
           <a:xfrm>
-            <a:off x="5120640" y="1097280"/>
+            <a:off x="5212080" y="1097280"/>
             <a:ext cx="3840480" cy="2160270"/>
           </a:xfrm>
           <a:prstGeom prst="rect">
@@ -2864,8 +2864,8 @@
         </p:nvSpPr>
         <p:spPr>
           <a:xfrm>
-            <a:off x="548640" y="1554480"/>
-            <a:ext cx="5120640" cy="1325880"/>
+            <a:off x="548640" y="1600200"/>
+            <a:ext cx="4480560" cy="1371600"/>
           </a:xfrm>
           <a:prstGeom prst="rect">
             <a:avLst/>
@@ -2878,10 +2878,13 @@
           <a:lstStyle/>
           <a:p>
             <a:pPr indent="0" marL="0">
-              <a:buNone/>
-            </a:pPr>
-            <a:r>
-              <a:rPr lang="en-US" sz="3400" dirty="0">
+              <a:lnSpc>
+                <a:spcPct val="115000"/>
+              </a:lnSpc>
+              <a:buNone/>
+            </a:pPr>
+            <a:r>
+              <a:rPr lang="en-US" sz="3200" dirty="0">
                 <a:solidFill>
                   <a:srgbClr val="DBE3EA"/>
                 </a:solidFill>
@@ -2891,14 +2894,17 @@
               </a:rPr>
               <a:t>The Mathematician's</a:t>
             </a:r>
-            <a:endParaRPr lang="en-US" sz="3400" dirty="0"/>
-          </a:p>
-          <a:p>
-            <a:pPr indent="0" marL="0">
-              <a:buNone/>
-            </a:pPr>
-            <a:r>
-              <a:rPr lang="en-US" sz="3400" dirty="0">
+            <a:endParaRPr lang="en-US" sz="3200" dirty="0"/>
+          </a:p>
+          <a:p>
+            <a:pPr indent="0" marL="0">
+              <a:lnSpc>
+                <a:spcPct val="115000"/>
+              </a:lnSpc>
+              <a:buNone/>
+            </a:pPr>
+            <a:r>
+              <a:rPr lang="en-US" sz="3200" dirty="0">
                 <a:solidFill>
                   <a:srgbClr val="DBE3EA"/>
                 </a:solidFill>
@@ -2908,7 +2914,7 @@
               </a:rPr>
               <a:t>Edge</a:t>
             </a:r>
-            <a:endParaRPr lang="en-US" sz="3400" dirty="0"/>
+            <a:endParaRPr lang="en-US" sz="3200" dirty="0"/>
           </a:p>
         </p:txBody>
       </p:sp>
@@ -2920,8 +2926,8 @@
         </p:nvSpPr>
         <p:spPr>
           <a:xfrm>
-            <a:off x="548640" y="3063240"/>
-            <a:ext cx="4389120" cy="731520"/>
+            <a:off x="548640" y="3154680"/>
+            <a:ext cx="4389120" cy="822960"/>
           </a:xfrm>
           <a:prstGeom prst="rect">
             <a:avLst/>
@@ -3069,8 +3075,8 @@
         </p:nvSpPr>
         <p:spPr>
           <a:xfrm>
-            <a:off x="457200" y="548640"/>
-            <a:ext cx="8229600" cy="594360"/>
+            <a:off x="457200" y="566928"/>
+            <a:ext cx="8229600" cy="548640"/>
           </a:xfrm>
           <a:prstGeom prst="rect">
             <a:avLst/>
@@ -3086,7 +3092,7 @@
               <a:buNone/>
             </a:pPr>
             <a:r>
-              <a:rPr lang="en-US" sz="2800" dirty="0">
+              <a:rPr lang="en-US" sz="2400" dirty="0">
                 <a:solidFill>
                   <a:srgbClr val="DBE3EA"/>
                 </a:solidFill>
@@ -3096,7 +3102,7 @@
               </a:rPr>
               <a:t>Medallion ko copy nahi kiya ja sakta</a:t>
             </a:r>
-            <a:endParaRPr lang="en-US" sz="2800" dirty="0"/>
+            <a:endParaRPr lang="en-US" sz="2400" dirty="0"/>
           </a:p>
         </p:txBody>
       </p:sp>
@@ -3444,8 +3450,8 @@
         </p:nvSpPr>
         <p:spPr>
           <a:xfrm>
-            <a:off x="457200" y="548640"/>
-            <a:ext cx="8229600" cy="594360"/>
+            <a:off x="457200" y="566928"/>
+            <a:ext cx="8229600" cy="548640"/>
           </a:xfrm>
           <a:prstGeom prst="rect">
             <a:avLst/>
@@ -3461,7 +3467,7 @@
               <a:buNone/>
             </a:pPr>
             <a:r>
-              <a:rPr lang="en-US" sz="2800" dirty="0">
+              <a:rPr lang="en-US" sz="2400" dirty="0">
                 <a:solidFill>
                   <a:srgbClr val="DBE3EA"/>
                 </a:solidFill>
@@ -3471,7 +3477,7 @@
               </a:rPr>
               <a:t>Rules aur evidence</a:t>
             </a:r>
-            <a:endParaRPr lang="en-US" sz="2800" dirty="0"/>
+            <a:endParaRPr lang="en-US" sz="2400" dirty="0"/>
           </a:p>
         </p:txBody>
       </p:sp>
@@ -3522,7 +3528,7 @@
         </p:nvSpPr>
         <p:spPr>
           <a:xfrm>
-            <a:off x="438912" y="1261872"/>
+            <a:off x="438912" y="1216152"/>
             <a:ext cx="4014216" cy="2273999"/>
           </a:xfrm>
           <a:prstGeom prst="rect">
@@ -3562,7 +3568,7 @@
         </p:blipFill>
         <p:spPr>
           <a:xfrm>
-            <a:off x="457200" y="1280160"/>
+            <a:off x="457200" y="1234440"/>
             <a:ext cx="3977640" cy="2237423"/>
           </a:xfrm>
           <a:prstGeom prst="rect">
@@ -3578,7 +3584,7 @@
         </p:nvSpPr>
         <p:spPr>
           <a:xfrm>
-            <a:off x="4690872" y="1261872"/>
+            <a:off x="4690872" y="1216152"/>
             <a:ext cx="4014216" cy="2273999"/>
           </a:xfrm>
           <a:prstGeom prst="rect">
@@ -3618,7 +3624,7 @@
         </p:blipFill>
         <p:spPr>
           <a:xfrm>
-            <a:off x="4709160" y="1280160"/>
+            <a:off x="4709160" y="1234440"/>
             <a:ext cx="3977640" cy="2237423"/>
           </a:xfrm>
           <a:prstGeom prst="rect">
@@ -3634,20 +3640,23 @@
         </p:nvSpPr>
         <p:spPr>
           <a:xfrm>
-            <a:off x="457200" y="3611880"/>
-            <a:ext cx="3977640" cy="274320"/>
-          </a:xfrm>
-          <a:prstGeom prst="rect">
-            <a:avLst/>
-          </a:prstGeom>
-          <a:noFill/>
-          <a:ln/>
-        </p:spPr>
-        <p:txBody>
-          <a:bodyPr wrap="square" lIns="0" tIns="0" rIns="0" bIns="0" rtlCol="0" anchor="ctr"/>
-          <a:lstStyle/>
-          <a:p>
-            <a:pPr indent="0" marL="0">
+            <a:off x="457200" y="3746183"/>
+            <a:ext cx="3977640" cy="1097280"/>
+          </a:xfrm>
+          <a:prstGeom prst="rect">
+            <a:avLst/>
+          </a:prstGeom>
+          <a:noFill/>
+          <a:ln/>
+        </p:spPr>
+        <p:txBody>
+          <a:bodyPr wrap="square" lIns="0" tIns="0" rIns="0" bIns="0" rtlCol="0" anchor="t"/>
+          <a:lstStyle/>
+          <a:p>
+            <a:pPr indent="0" marL="0">
+              <a:spcAft>
+                <a:spcPts val="300"/>
+              </a:spcAft>
               <a:buNone/>
             </a:pPr>
             <a:r>
@@ -3663,6 +3672,23 @@
             </a:r>
             <a:endParaRPr lang="en-US" sz="1300" dirty="0"/>
           </a:p>
+          <a:p>
+            <a:pPr indent="0" marL="0">
+              <a:buNone/>
+            </a:pPr>
+            <a:r>
+              <a:rPr lang="en-US" sz="1200" dirty="0">
+                <a:solidFill>
+                  <a:srgbClr val="DBE3EA"/>
+                </a:solidFill>
+                <a:latin typeface="Calibri" pitchFamily="34" charset="0"/>
+                <a:ea typeface="Calibri" pitchFamily="34" charset="-122"/>
+                <a:cs typeface="Calibri" pitchFamily="34" charset="-120"/>
+              </a:rPr>
+              <a:t>Entry, exit, stop loss, position size pehle se define karo</a:t>
+            </a:r>
+            <a:endParaRPr lang="en-US" sz="1300" dirty="0"/>
+          </a:p>
         </p:txBody>
       </p:sp>
       <p:sp>
@@ -3673,8 +3699,8 @@
         </p:nvSpPr>
         <p:spPr>
           <a:xfrm>
-            <a:off x="457200" y="3904488"/>
-            <a:ext cx="3977640" cy="457200"/>
+            <a:off x="4709160" y="3746183"/>
+            <a:ext cx="3977640" cy="1097280"/>
           </a:xfrm>
           <a:prstGeom prst="rect">
             <a:avLst/>
@@ -3687,6 +3713,26 @@
           <a:lstStyle/>
           <a:p>
             <a:pPr indent="0" marL="0">
+              <a:spcAft>
+                <a:spcPts val="300"/>
+              </a:spcAft>
+              <a:buNone/>
+            </a:pPr>
+            <a:r>
+              <a:rPr lang="en-US" sz="1300" b="1" dirty="0">
+                <a:solidFill>
+                  <a:srgbClr val="C8FF4D"/>
+                </a:solidFill>
+                <a:latin typeface="Calibri" pitchFamily="34" charset="0"/>
+                <a:ea typeface="Calibri" pitchFamily="34" charset="-122"/>
+                <a:cs typeface="Calibri" pitchFamily="34" charset="-120"/>
+              </a:rPr>
+              <a:t>2 · Data &amp; evidence &gt; narrative</a:t>
+            </a:r>
+            <a:endParaRPr lang="en-US" sz="1300" dirty="0"/>
+          </a:p>
+          <a:p>
+            <a:pPr indent="0" marL="0">
               <a:buNone/>
             </a:pPr>
             <a:r>
@@ -3698,87 +3744,9 @@
                 <a:ea typeface="Calibri" pitchFamily="34" charset="-122"/>
                 <a:cs typeface="Calibri" pitchFamily="34" charset="-120"/>
               </a:rPr>
-              <a:t>Entry, exit, stop loss, position size pehle se define karo</a:t>
-            </a:r>
-            <a:endParaRPr lang="en-US" sz="1200" dirty="0"/>
-          </a:p>
-        </p:txBody>
-      </p:sp>
-      <p:sp>
-        <p:nvSpPr>
-          <p:cNvPr id="11" name="Text 7"/>
-          <p:cNvSpPr txBox="1"/>
-          <p:nvPr/>
-        </p:nvSpPr>
-        <p:spPr>
-          <a:xfrm>
-            <a:off x="4709160" y="3611880"/>
-            <a:ext cx="3977640" cy="274320"/>
-          </a:xfrm>
-          <a:prstGeom prst="rect">
-            <a:avLst/>
-          </a:prstGeom>
-          <a:noFill/>
-          <a:ln/>
-        </p:spPr>
-        <p:txBody>
-          <a:bodyPr wrap="square" lIns="0" tIns="0" rIns="0" bIns="0" rtlCol="0" anchor="ctr"/>
-          <a:lstStyle/>
-          <a:p>
-            <a:pPr indent="0" marL="0">
-              <a:buNone/>
-            </a:pPr>
-            <a:r>
-              <a:rPr lang="en-US" sz="1300" b="1" dirty="0">
-                <a:solidFill>
-                  <a:srgbClr val="C8FF4D"/>
-                </a:solidFill>
-                <a:latin typeface="Calibri" pitchFamily="34" charset="0"/>
-                <a:ea typeface="Calibri" pitchFamily="34" charset="-122"/>
-                <a:cs typeface="Calibri" pitchFamily="34" charset="-120"/>
-              </a:rPr>
-              <a:t>2 · Data &amp; evidence &gt; narrative</a:t>
+              <a:t>Backtest karo — lekin backtest guarantee nahi, baseline hai</a:t>
             </a:r>
             <a:endParaRPr lang="en-US" sz="1300" dirty="0"/>
-          </a:p>
-        </p:txBody>
-      </p:sp>
-      <p:sp>
-        <p:nvSpPr>
-          <p:cNvPr id="12" name="Text 8"/>
-          <p:cNvSpPr txBox="1"/>
-          <p:nvPr/>
-        </p:nvSpPr>
-        <p:spPr>
-          <a:xfrm>
-            <a:off x="4709160" y="3904488"/>
-            <a:ext cx="3977640" cy="457200"/>
-          </a:xfrm>
-          <a:prstGeom prst="rect">
-            <a:avLst/>
-          </a:prstGeom>
-          <a:noFill/>
-          <a:ln/>
-        </p:spPr>
-        <p:txBody>
-          <a:bodyPr wrap="square" lIns="0" tIns="0" rIns="0" bIns="0" rtlCol="0" anchor="t"/>
-          <a:lstStyle/>
-          <a:p>
-            <a:pPr indent="0" marL="0">
-              <a:buNone/>
-            </a:pPr>
-            <a:r>
-              <a:rPr lang="en-US" sz="1200" dirty="0">
-                <a:solidFill>
-                  <a:srgbClr val="DBE3EA"/>
-                </a:solidFill>
-                <a:latin typeface="Calibri" pitchFamily="34" charset="0"/>
-                <a:ea typeface="Calibri" pitchFamily="34" charset="-122"/>
-                <a:cs typeface="Calibri" pitchFamily="34" charset="-120"/>
-              </a:rPr>
-              <a:t>Backtest karo — lekin backtest guarantee nahi, baseline hai</a:t>
-            </a:r>
-            <a:endParaRPr lang="en-US" sz="1200" dirty="0"/>
           </a:p>
         </p:txBody>
       </p:sp>
@@ -3861,8 +3829,8 @@
         </p:nvSpPr>
         <p:spPr>
           <a:xfrm>
-            <a:off x="457200" y="548640"/>
-            <a:ext cx="8229600" cy="594360"/>
+            <a:off x="457200" y="566928"/>
+            <a:ext cx="8229600" cy="548640"/>
           </a:xfrm>
           <a:prstGeom prst="rect">
             <a:avLst/>
@@ -3878,7 +3846,7 @@
               <a:buNone/>
             </a:pPr>
             <a:r>
-              <a:rPr lang="en-US" sz="2800" dirty="0">
+              <a:rPr lang="en-US" sz="2400" dirty="0">
                 <a:solidFill>
                   <a:srgbClr val="DBE3EA"/>
                 </a:solidFill>
@@ -3888,7 +3856,7 @@
               </a:rPr>
               <a:t>Risk aur diversification</a:t>
             </a:r>
-            <a:endParaRPr lang="en-US" sz="2800" dirty="0"/>
+            <a:endParaRPr lang="en-US" sz="2400" dirty="0"/>
           </a:p>
         </p:txBody>
       </p:sp>
@@ -3939,7 +3907,7 @@
         </p:nvSpPr>
         <p:spPr>
           <a:xfrm>
-            <a:off x="438912" y="1261872"/>
+            <a:off x="438912" y="1216152"/>
             <a:ext cx="4014216" cy="2273999"/>
           </a:xfrm>
           <a:prstGeom prst="rect">
@@ -3979,7 +3947,7 @@
         </p:blipFill>
         <p:spPr>
           <a:xfrm>
-            <a:off x="457200" y="1280160"/>
+            <a:off x="457200" y="1234440"/>
             <a:ext cx="3977640" cy="2237423"/>
           </a:xfrm>
           <a:prstGeom prst="rect">
@@ -3995,7 +3963,7 @@
         </p:nvSpPr>
         <p:spPr>
           <a:xfrm>
-            <a:off x="4690872" y="1261872"/>
+            <a:off x="4690872" y="1216152"/>
             <a:ext cx="4014216" cy="2273999"/>
           </a:xfrm>
           <a:prstGeom prst="rect">
@@ -4035,7 +4003,7 @@
         </p:blipFill>
         <p:spPr>
           <a:xfrm>
-            <a:off x="4709160" y="1280160"/>
+            <a:off x="4709160" y="1234440"/>
             <a:ext cx="3977640" cy="2237423"/>
           </a:xfrm>
           <a:prstGeom prst="rect">
@@ -4051,20 +4019,23 @@
         </p:nvSpPr>
         <p:spPr>
           <a:xfrm>
-            <a:off x="457200" y="3611880"/>
-            <a:ext cx="3977640" cy="274320"/>
-          </a:xfrm>
-          <a:prstGeom prst="rect">
-            <a:avLst/>
-          </a:prstGeom>
-          <a:noFill/>
-          <a:ln/>
-        </p:spPr>
-        <p:txBody>
-          <a:bodyPr wrap="square" lIns="0" tIns="0" rIns="0" bIns="0" rtlCol="0" anchor="ctr"/>
-          <a:lstStyle/>
-          <a:p>
-            <a:pPr indent="0" marL="0">
+            <a:off x="457200" y="3746183"/>
+            <a:ext cx="3977640" cy="1097280"/>
+          </a:xfrm>
+          <a:prstGeom prst="rect">
+            <a:avLst/>
+          </a:prstGeom>
+          <a:noFill/>
+          <a:ln/>
+        </p:spPr>
+        <p:txBody>
+          <a:bodyPr wrap="square" lIns="0" tIns="0" rIns="0" bIns="0" rtlCol="0" anchor="t"/>
+          <a:lstStyle/>
+          <a:p>
+            <a:pPr indent="0" marL="0">
+              <a:spcAft>
+                <a:spcPts val="300"/>
+              </a:spcAft>
               <a:buNone/>
             </a:pPr>
             <a:r>
@@ -4080,6 +4051,23 @@
             </a:r>
             <a:endParaRPr lang="en-US" sz="1300" dirty="0"/>
           </a:p>
+          <a:p>
+            <a:pPr indent="0" marL="0">
+              <a:buNone/>
+            </a:pPr>
+            <a:r>
+              <a:rPr lang="en-US" sz="1200" dirty="0">
+                <a:solidFill>
+                  <a:srgbClr val="DBE3EA"/>
+                </a:solidFill>
+                <a:latin typeface="Calibri" pitchFamily="34" charset="0"/>
+                <a:ea typeface="Calibri" pitchFamily="34" charset="-122"/>
+                <a:cs typeface="Calibri" pitchFamily="34" charset="-120"/>
+              </a:rPr>
+              <a:t>Har trade + daily/weekly max loss; winning streak mein risk mat badhao</a:t>
+            </a:r>
+            <a:endParaRPr lang="en-US" sz="1300" dirty="0"/>
+          </a:p>
         </p:txBody>
       </p:sp>
       <p:sp>
@@ -4090,8 +4078,8 @@
         </p:nvSpPr>
         <p:spPr>
           <a:xfrm>
-            <a:off x="457200" y="3904488"/>
-            <a:ext cx="3977640" cy="457200"/>
+            <a:off x="4709160" y="3746183"/>
+            <a:ext cx="3977640" cy="1097280"/>
           </a:xfrm>
           <a:prstGeom prst="rect">
             <a:avLst/>
@@ -4104,6 +4092,26 @@
           <a:lstStyle/>
           <a:p>
             <a:pPr indent="0" marL="0">
+              <a:spcAft>
+                <a:spcPts val="300"/>
+              </a:spcAft>
+              <a:buNone/>
+            </a:pPr>
+            <a:r>
+              <a:rPr lang="en-US" sz="1300" b="1" dirty="0">
+                <a:solidFill>
+                  <a:srgbClr val="C8FF4D"/>
+                </a:solidFill>
+                <a:latin typeface="Calibri" pitchFamily="34" charset="0"/>
+                <a:ea typeface="Calibri" pitchFamily="34" charset="-122"/>
+                <a:cs typeface="Calibri" pitchFamily="34" charset="-120"/>
+              </a:rPr>
+              <a:t>4 · Diversify karo</a:t>
+            </a:r>
+            <a:endParaRPr lang="en-US" sz="1300" dirty="0"/>
+          </a:p>
+          <a:p>
+            <a:pPr indent="0" marL="0">
               <a:buNone/>
             </a:pPr>
             <a:r>
@@ -4115,87 +4123,9 @@
                 <a:ea typeface="Calibri" pitchFamily="34" charset="-122"/>
                 <a:cs typeface="Calibri" pitchFamily="34" charset="-120"/>
               </a:rPr>
-              <a:t>Har trade + daily/weekly max loss; winning streak mein risk mat badhao</a:t>
-            </a:r>
-            <a:endParaRPr lang="en-US" sz="1200" dirty="0"/>
-          </a:p>
-        </p:txBody>
-      </p:sp>
-      <p:sp>
-        <p:nvSpPr>
-          <p:cNvPr id="11" name="Text 7"/>
-          <p:cNvSpPr txBox="1"/>
-          <p:nvPr/>
-        </p:nvSpPr>
-        <p:spPr>
-          <a:xfrm>
-            <a:off x="4709160" y="3611880"/>
-            <a:ext cx="3977640" cy="274320"/>
-          </a:xfrm>
-          <a:prstGeom prst="rect">
-            <a:avLst/>
-          </a:prstGeom>
-          <a:noFill/>
-          <a:ln/>
-        </p:spPr>
-        <p:txBody>
-          <a:bodyPr wrap="square" lIns="0" tIns="0" rIns="0" bIns="0" rtlCol="0" anchor="ctr"/>
-          <a:lstStyle/>
-          <a:p>
-            <a:pPr indent="0" marL="0">
-              <a:buNone/>
-            </a:pPr>
-            <a:r>
-              <a:rPr lang="en-US" sz="1300" b="1" dirty="0">
-                <a:solidFill>
-                  <a:srgbClr val="C8FF4D"/>
-                </a:solidFill>
-                <a:latin typeface="Calibri" pitchFamily="34" charset="0"/>
-                <a:ea typeface="Calibri" pitchFamily="34" charset="-122"/>
-                <a:cs typeface="Calibri" pitchFamily="34" charset="-120"/>
-              </a:rPr>
-              <a:t>4 · Diversify karo</a:t>
+              <a:t>Ek instrument ya ek strategy par poori tarah dependent mat raho</a:t>
             </a:r>
             <a:endParaRPr lang="en-US" sz="1300" dirty="0"/>
-          </a:p>
-        </p:txBody>
-      </p:sp>
-      <p:sp>
-        <p:nvSpPr>
-          <p:cNvPr id="12" name="Text 8"/>
-          <p:cNvSpPr txBox="1"/>
-          <p:nvPr/>
-        </p:nvSpPr>
-        <p:spPr>
-          <a:xfrm>
-            <a:off x="4709160" y="3904488"/>
-            <a:ext cx="3977640" cy="457200"/>
-          </a:xfrm>
-          <a:prstGeom prst="rect">
-            <a:avLst/>
-          </a:prstGeom>
-          <a:noFill/>
-          <a:ln/>
-        </p:spPr>
-        <p:txBody>
-          <a:bodyPr wrap="square" lIns="0" tIns="0" rIns="0" bIns="0" rtlCol="0" anchor="t"/>
-          <a:lstStyle/>
-          <a:p>
-            <a:pPr indent="0" marL="0">
-              <a:buNone/>
-            </a:pPr>
-            <a:r>
-              <a:rPr lang="en-US" sz="1200" dirty="0">
-                <a:solidFill>
-                  <a:srgbClr val="DBE3EA"/>
-                </a:solidFill>
-                <a:latin typeface="Calibri" pitchFamily="34" charset="0"/>
-                <a:ea typeface="Calibri" pitchFamily="34" charset="-122"/>
-                <a:cs typeface="Calibri" pitchFamily="34" charset="-120"/>
-              </a:rPr>
-              <a:t>Ek instrument ya ek strategy par poori tarah dependent mat raho</a:t>
-            </a:r>
-            <a:endParaRPr lang="en-US" sz="1200" dirty="0"/>
           </a:p>
         </p:txBody>
       </p:sp>
@@ -4278,8 +4208,8 @@
         </p:nvSpPr>
         <p:spPr>
           <a:xfrm>
-            <a:off x="457200" y="548640"/>
-            <a:ext cx="8229600" cy="594360"/>
+            <a:off x="457200" y="566928"/>
+            <a:ext cx="8229600" cy="548640"/>
           </a:xfrm>
           <a:prstGeom prst="rect">
             <a:avLst/>
@@ -4295,7 +4225,7 @@
               <a:buNone/>
             </a:pPr>
             <a:r>
-              <a:rPr lang="en-US" sz="2800" dirty="0">
+              <a:rPr lang="en-US" sz="2400" dirty="0">
                 <a:solidFill>
                   <a:srgbClr val="DBE3EA"/>
                 </a:solidFill>
@@ -4305,7 +4235,7 @@
               </a:rPr>
               <a:t>Quantitative strategies ke 4 types</a:t>
             </a:r>
-            <a:endParaRPr lang="en-US" sz="2800" dirty="0"/>
+            <a:endParaRPr lang="en-US" sz="2400" dirty="0"/>
           </a:p>
         </p:txBody>
       </p:sp>
@@ -4381,19 +4311,22 @@
         <p:spPr>
           <a:xfrm>
             <a:off x="2606040" y="1280160"/>
-            <a:ext cx="1920240" cy="320040"/>
-          </a:xfrm>
-          <a:prstGeom prst="rect">
-            <a:avLst/>
-          </a:prstGeom>
-          <a:noFill/>
-          <a:ln/>
-        </p:spPr>
-        <p:txBody>
-          <a:bodyPr wrap="square" lIns="0" tIns="0" rIns="0" bIns="0" rtlCol="0" anchor="ctr"/>
-          <a:lstStyle/>
-          <a:p>
-            <a:pPr indent="0" marL="0">
+            <a:ext cx="1965960" cy="1600200"/>
+          </a:xfrm>
+          <a:prstGeom prst="rect">
+            <a:avLst/>
+          </a:prstGeom>
+          <a:noFill/>
+          <a:ln/>
+        </p:spPr>
+        <p:txBody>
+          <a:bodyPr wrap="square" lIns="0" tIns="0" rIns="0" bIns="0" rtlCol="0" anchor="t"/>
+          <a:lstStyle/>
+          <a:p>
+            <a:pPr indent="0" marL="0">
+              <a:spcAft>
+                <a:spcPts val="300"/>
+              </a:spcAft>
               <a:buNone/>
             </a:pPr>
             <a:r>
@@ -4409,28 +4342,6 @@
             </a:r>
             <a:endParaRPr lang="en-US" sz="1300" dirty="0"/>
           </a:p>
-        </p:txBody>
-      </p:sp>
-      <p:sp>
-        <p:nvSpPr>
-          <p:cNvPr id="7" name="Text 4"/>
-          <p:cNvSpPr txBox="1"/>
-          <p:nvPr/>
-        </p:nvSpPr>
-        <p:spPr>
-          <a:xfrm>
-            <a:off x="2606040" y="1627632"/>
-            <a:ext cx="1920240" cy="822960"/>
-          </a:xfrm>
-          <a:prstGeom prst="rect">
-            <a:avLst/>
-          </a:prstGeom>
-          <a:noFill/>
-          <a:ln/>
-        </p:spPr>
-        <p:txBody>
-          <a:bodyPr wrap="square" lIns="0" tIns="0" rIns="0" bIns="0" rtlCol="0" anchor="t"/>
-          <a:lstStyle/>
           <a:p>
             <a:pPr indent="0" marL="0">
               <a:buNone/>
@@ -4446,13 +4357,13 @@
               </a:rPr>
               <a:t>Related assets ka spread normal range ki taraf revert karega?</a:t>
             </a:r>
-            <a:endParaRPr lang="en-US" sz="1100" dirty="0"/>
+            <a:endParaRPr lang="en-US" sz="1300" dirty="0"/>
           </a:p>
         </p:txBody>
       </p:sp>
       <p:pic>
         <p:nvPicPr>
-          <p:cNvPr id="8" name="Image 1" descr="Video frame, scene S19">    </p:cNvPr>
+          <p:cNvPr id="7" name="Image 1" descr="Video frame, scene S19">    </p:cNvPr>
           <p:cNvPicPr>
             <a:picLocks noChangeAspect="1"/>
           </p:cNvPicPr>
@@ -4476,26 +4387,29 @@
       </p:pic>
       <p:sp>
         <p:nvSpPr>
-          <p:cNvPr id="9" name="Text 5"/>
+          <p:cNvPr id="8" name="Text 4"/>
           <p:cNvSpPr txBox="1"/>
           <p:nvPr/>
         </p:nvSpPr>
         <p:spPr>
           <a:xfrm>
             <a:off x="6812280" y="1280160"/>
-            <a:ext cx="1920240" cy="320040"/>
-          </a:xfrm>
-          <a:prstGeom prst="rect">
-            <a:avLst/>
-          </a:prstGeom>
-          <a:noFill/>
-          <a:ln/>
-        </p:spPr>
-        <p:txBody>
-          <a:bodyPr wrap="square" lIns="0" tIns="0" rIns="0" bIns="0" rtlCol="0" anchor="ctr"/>
-          <a:lstStyle/>
-          <a:p>
-            <a:pPr indent="0" marL="0">
+            <a:ext cx="1965960" cy="1600200"/>
+          </a:xfrm>
+          <a:prstGeom prst="rect">
+            <a:avLst/>
+          </a:prstGeom>
+          <a:noFill/>
+          <a:ln/>
+        </p:spPr>
+        <p:txBody>
+          <a:bodyPr wrap="square" lIns="0" tIns="0" rIns="0" bIns="0" rtlCol="0" anchor="t"/>
+          <a:lstStyle/>
+          <a:p>
+            <a:pPr indent="0" marL="0">
+              <a:spcAft>
+                <a:spcPts val="300"/>
+              </a:spcAft>
               <a:buNone/>
             </a:pPr>
             <a:r>
@@ -4511,28 +4425,6 @@
             </a:r>
             <a:endParaRPr lang="en-US" sz="1300" dirty="0"/>
           </a:p>
-        </p:txBody>
-      </p:sp>
-      <p:sp>
-        <p:nvSpPr>
-          <p:cNvPr id="10" name="Text 6"/>
-          <p:cNvSpPr txBox="1"/>
-          <p:nvPr/>
-        </p:nvSpPr>
-        <p:spPr>
-          <a:xfrm>
-            <a:off x="6812280" y="1627632"/>
-            <a:ext cx="1920240" cy="822960"/>
-          </a:xfrm>
-          <a:prstGeom prst="rect">
-            <a:avLst/>
-          </a:prstGeom>
-          <a:noFill/>
-          <a:ln/>
-        </p:spPr>
-        <p:txBody>
-          <a:bodyPr wrap="square" lIns="0" tIns="0" rIns="0" bIns="0" rtlCol="0" anchor="t"/>
-          <a:lstStyle/>
           <a:p>
             <a:pPr indent="0" marL="0">
               <a:buNone/>
@@ -4548,13 +4440,13 @@
               </a:rPr>
               <a:t>Uptrend mein long, downtrend mein short</a:t>
             </a:r>
-            <a:endParaRPr lang="en-US" sz="1100" dirty="0"/>
+            <a:endParaRPr lang="en-US" sz="1300" dirty="0"/>
           </a:p>
         </p:txBody>
       </p:sp>
       <p:pic>
         <p:nvPicPr>
-          <p:cNvPr id="11" name="Image 2" descr="Video frame, scene S20">    </p:cNvPr>
+          <p:cNvPr id="9" name="Image 2" descr="Video frame, scene S20">    </p:cNvPr>
           <p:cNvPicPr>
             <a:picLocks noChangeAspect="1"/>
           </p:cNvPicPr>
@@ -4578,26 +4470,29 @@
       </p:pic>
       <p:sp>
         <p:nvSpPr>
-          <p:cNvPr id="12" name="Text 7"/>
+          <p:cNvPr id="10" name="Text 5"/>
           <p:cNvSpPr txBox="1"/>
           <p:nvPr/>
         </p:nvSpPr>
         <p:spPr>
           <a:xfrm>
             <a:off x="2606040" y="3108960"/>
-            <a:ext cx="1920240" cy="320040"/>
-          </a:xfrm>
-          <a:prstGeom prst="rect">
-            <a:avLst/>
-          </a:prstGeom>
-          <a:noFill/>
-          <a:ln/>
-        </p:spPr>
-        <p:txBody>
-          <a:bodyPr wrap="square" lIns="0" tIns="0" rIns="0" bIns="0" rtlCol="0" anchor="ctr"/>
-          <a:lstStyle/>
-          <a:p>
-            <a:pPr indent="0" marL="0">
+            <a:ext cx="1965960" cy="1600200"/>
+          </a:xfrm>
+          <a:prstGeom prst="rect">
+            <a:avLst/>
+          </a:prstGeom>
+          <a:noFill/>
+          <a:ln/>
+        </p:spPr>
+        <p:txBody>
+          <a:bodyPr wrap="square" lIns="0" tIns="0" rIns="0" bIns="0" rtlCol="0" anchor="t"/>
+          <a:lstStyle/>
+          <a:p>
+            <a:pPr indent="0" marL="0">
+              <a:spcAft>
+                <a:spcPts val="300"/>
+              </a:spcAft>
               <a:buNone/>
             </a:pPr>
             <a:r>
@@ -4613,28 +4508,6 @@
             </a:r>
             <a:endParaRPr lang="en-US" sz="1300" dirty="0"/>
           </a:p>
-        </p:txBody>
-      </p:sp>
-      <p:sp>
-        <p:nvSpPr>
-          <p:cNvPr id="13" name="Text 8"/>
-          <p:cNvSpPr txBox="1"/>
-          <p:nvPr/>
-        </p:nvSpPr>
-        <p:spPr>
-          <a:xfrm>
-            <a:off x="2606040" y="3456432"/>
-            <a:ext cx="1920240" cy="822960"/>
-          </a:xfrm>
-          <a:prstGeom prst="rect">
-            <a:avLst/>
-          </a:prstGeom>
-          <a:noFill/>
-          <a:ln/>
-        </p:spPr>
-        <p:txBody>
-          <a:bodyPr wrap="square" lIns="0" tIns="0" rIns="0" bIns="0" rtlCol="0" anchor="t"/>
-          <a:lstStyle/>
           <a:p>
             <a:pPr indent="0" marL="0">
               <a:buNone/>
@@ -4650,13 +4523,13 @@
               </a:rPr>
               <a:t>Temporary overextension hai ya new trend?</a:t>
             </a:r>
-            <a:endParaRPr lang="en-US" sz="1100" dirty="0"/>
+            <a:endParaRPr lang="en-US" sz="1300" dirty="0"/>
           </a:p>
         </p:txBody>
       </p:sp>
       <p:pic>
         <p:nvPicPr>
-          <p:cNvPr id="14" name="Image 3" descr="Video frame, scene S21">    </p:cNvPr>
+          <p:cNvPr id="11" name="Image 3" descr="Video frame, scene S21">    </p:cNvPr>
           <p:cNvPicPr>
             <a:picLocks noChangeAspect="1"/>
           </p:cNvPicPr>
@@ -4680,26 +4553,29 @@
       </p:pic>
       <p:sp>
         <p:nvSpPr>
-          <p:cNvPr id="15" name="Text 9"/>
+          <p:cNvPr id="12" name="Text 6"/>
           <p:cNvSpPr txBox="1"/>
           <p:nvPr/>
         </p:nvSpPr>
         <p:spPr>
           <a:xfrm>
             <a:off x="6812280" y="3108960"/>
-            <a:ext cx="1920240" cy="320040"/>
-          </a:xfrm>
-          <a:prstGeom prst="rect">
-            <a:avLst/>
-          </a:prstGeom>
-          <a:noFill/>
-          <a:ln/>
-        </p:spPr>
-        <p:txBody>
-          <a:bodyPr wrap="square" lIns="0" tIns="0" rIns="0" bIns="0" rtlCol="0" anchor="ctr"/>
-          <a:lstStyle/>
-          <a:p>
-            <a:pPr indent="0" marL="0">
+            <a:ext cx="1965960" cy="1600200"/>
+          </a:xfrm>
+          <a:prstGeom prst="rect">
+            <a:avLst/>
+          </a:prstGeom>
+          <a:noFill/>
+          <a:ln/>
+        </p:spPr>
+        <p:txBody>
+          <a:bodyPr wrap="square" lIns="0" tIns="0" rIns="0" bIns="0" rtlCol="0" anchor="t"/>
+          <a:lstStyle/>
+          <a:p>
+            <a:pPr indent="0" marL="0">
+              <a:spcAft>
+                <a:spcPts val="300"/>
+              </a:spcAft>
               <a:buNone/>
             </a:pPr>
             <a:r>
@@ -4715,28 +4591,6 @@
             </a:r>
             <a:endParaRPr lang="en-US" sz="1300" dirty="0"/>
           </a:p>
-        </p:txBody>
-      </p:sp>
-      <p:sp>
-        <p:nvSpPr>
-          <p:cNvPr id="16" name="Text 10"/>
-          <p:cNvSpPr txBox="1"/>
-          <p:nvPr/>
-        </p:nvSpPr>
-        <p:spPr>
-          <a:xfrm>
-            <a:off x="6812280" y="3456432"/>
-            <a:ext cx="1920240" cy="822960"/>
-          </a:xfrm>
-          <a:prstGeom prst="rect">
-            <a:avLst/>
-          </a:prstGeom>
-          <a:noFill/>
-          <a:ln/>
-        </p:spPr>
-        <p:txBody>
-          <a:bodyPr wrap="square" lIns="0" tIns="0" rIns="0" bIns="0" rtlCol="0" anchor="t"/>
-          <a:lstStyle/>
           <a:p>
             <a:pPr indent="0" marL="0">
               <a:buNone/>
@@ -4752,7 +4606,7 @@
               </a:rPr>
               <a:t>Stock predict nahi — portfolio ko tilt karo</a:t>
             </a:r>
-            <a:endParaRPr lang="en-US" sz="1100" dirty="0"/>
+            <a:endParaRPr lang="en-US" sz="1300" dirty="0"/>
           </a:p>
         </p:txBody>
       </p:sp>
@@ -4835,8 +4689,8 @@
         </p:nvSpPr>
         <p:spPr>
           <a:xfrm>
-            <a:off x="457200" y="548640"/>
-            <a:ext cx="8229600" cy="594360"/>
+            <a:off x="457200" y="566928"/>
+            <a:ext cx="8229600" cy="548640"/>
           </a:xfrm>
           <a:prstGeom prst="rect">
             <a:avLst/>
@@ -4852,7 +4706,7 @@
               <a:buNone/>
             </a:pPr>
             <a:r>
-              <a:rPr lang="en-US" sz="2800" dirty="0">
+              <a:rPr lang="en-US" sz="2400" dirty="0">
                 <a:solidFill>
                   <a:srgbClr val="DBE3EA"/>
                 </a:solidFill>
@@ -4862,7 +4716,7 @@
               </a:rPr>
               <a:t>Ek precise, testable rule se shuru karo</a:t>
             </a:r>
-            <a:endParaRPr lang="en-US" sz="2800" dirty="0"/>
+            <a:endParaRPr lang="en-US" sz="2400" dirty="0"/>
           </a:p>
         </p:txBody>
       </p:sp>
@@ -5372,8 +5226,8 @@
         </p:nvSpPr>
         <p:spPr>
           <a:xfrm>
-            <a:off x="457200" y="548640"/>
-            <a:ext cx="8229600" cy="594360"/>
+            <a:off x="457200" y="566928"/>
+            <a:ext cx="8229600" cy="548640"/>
           </a:xfrm>
           <a:prstGeom prst="rect">
             <a:avLst/>
@@ -5389,7 +5243,7 @@
               <a:buNone/>
             </a:pPr>
             <a:r>
-              <a:rPr lang="en-US" sz="2800" dirty="0">
+              <a:rPr lang="en-US" sz="2400" dirty="0">
                 <a:solidFill>
                   <a:srgbClr val="DBE3EA"/>
                 </a:solidFill>
@@ -5399,7 +5253,7 @@
               </a:rPr>
               <a:t>Execute karna sabse mushkil hai</a:t>
             </a:r>
-            <a:endParaRPr lang="en-US" sz="2800" dirty="0"/>
+            <a:endParaRPr lang="en-US" sz="2400" dirty="0"/>
           </a:p>
         </p:txBody>
       </p:sp>
@@ -5989,8 +5843,8 @@
         </p:nvSpPr>
         <p:spPr>
           <a:xfrm>
-            <a:off x="457200" y="548640"/>
-            <a:ext cx="8229600" cy="594360"/>
+            <a:off x="457200" y="566928"/>
+            <a:ext cx="8229600" cy="548640"/>
           </a:xfrm>
           <a:prstGeom prst="rect">
             <a:avLst/>
@@ -6006,7 +5860,7 @@
               <a:buNone/>
             </a:pPr>
             <a:r>
-              <a:rPr lang="en-US" sz="2800" dirty="0">
+              <a:rPr lang="en-US" sz="2400" dirty="0">
                 <a:solidFill>
                   <a:srgbClr val="DBE3EA"/>
                 </a:solidFill>
@@ -6016,7 +5870,7 @@
               </a:rPr>
               <a:t>Trade journal maintain karo</a:t>
             </a:r>
-            <a:endParaRPr lang="en-US" sz="2800" dirty="0"/>
+            <a:endParaRPr lang="en-US" sz="2400" dirty="0"/>
           </a:p>
         </p:txBody>
       </p:sp>
@@ -6327,8 +6181,8 @@
         </p:nvSpPr>
         <p:spPr>
           <a:xfrm>
-            <a:off x="457200" y="548640"/>
-            <a:ext cx="8229600" cy="594360"/>
+            <a:off x="457200" y="566928"/>
+            <a:ext cx="8229600" cy="548640"/>
           </a:xfrm>
           <a:prstGeom prst="rect">
             <a:avLst/>
@@ -6344,7 +6198,7 @@
               <a:buNone/>
             </a:pPr>
             <a:r>
-              <a:rPr lang="en-US" sz="2800" dirty="0">
+              <a:rPr lang="en-US" sz="2400" dirty="0">
                 <a:solidFill>
                   <a:srgbClr val="DBE3EA"/>
                 </a:solidFill>
@@ -6354,7 +6208,7 @@
               </a:rPr>
               <a:t>Normal drawdown — ya edge badal gayi?</a:t>
             </a:r>
-            <a:endParaRPr lang="en-US" sz="2800" dirty="0"/>
+            <a:endParaRPr lang="en-US" sz="2400" dirty="0"/>
           </a:p>
         </p:txBody>
       </p:sp>
@@ -6983,8 +6837,8 @@
         </p:nvSpPr>
         <p:spPr>
           <a:xfrm>
-            <a:off x="457200" y="548640"/>
-            <a:ext cx="8229600" cy="594360"/>
+            <a:off x="457200" y="566928"/>
+            <a:ext cx="8229600" cy="548640"/>
           </a:xfrm>
           <a:prstGeom prst="rect">
             <a:avLst/>
@@ -7000,7 +6854,7 @@
               <a:buNone/>
             </a:pPr>
             <a:r>
-              <a:rPr lang="en-US" sz="2800" dirty="0">
+              <a:rPr lang="en-US" sz="2400" dirty="0">
                 <a:solidFill>
                   <a:srgbClr val="DBE3EA"/>
                 </a:solidFill>
@@ -7010,7 +6864,7 @@
               </a:rPr>
               <a:t>Sabse bada trap: overfitting</a:t>
             </a:r>
-            <a:endParaRPr lang="en-US" sz="2800" dirty="0"/>
+            <a:endParaRPr lang="en-US" sz="2400" dirty="0"/>
           </a:p>
         </p:txBody>
       </p:sp>
@@ -7321,8 +7175,8 @@
         </p:nvSpPr>
         <p:spPr>
           <a:xfrm>
-            <a:off x="457200" y="548640"/>
-            <a:ext cx="8229600" cy="594360"/>
+            <a:off x="457200" y="566928"/>
+            <a:ext cx="8229600" cy="548640"/>
           </a:xfrm>
           <a:prstGeom prst="rect">
             <a:avLst/>
@@ -7338,7 +7192,7 @@
               <a:buNone/>
             </a:pPr>
             <a:r>
-              <a:rPr lang="en-US" sz="2800" dirty="0">
+              <a:rPr lang="en-US" sz="2400" dirty="0">
                 <a:solidFill>
                   <a:srgbClr val="DBE3EA"/>
                 </a:solidFill>
@@ -7348,7 +7202,7 @@
               </a:rPr>
               <a:t>Hidden costs aur fading edge</a:t>
             </a:r>
-            <a:endParaRPr lang="en-US" sz="2800" dirty="0"/>
+            <a:endParaRPr lang="en-US" sz="2400" dirty="0"/>
           </a:p>
         </p:txBody>
       </p:sp>
@@ -7399,7 +7253,7 @@
         </p:nvSpPr>
         <p:spPr>
           <a:xfrm>
-            <a:off x="438912" y="1261872"/>
+            <a:off x="438912" y="1216152"/>
             <a:ext cx="4014216" cy="2273999"/>
           </a:xfrm>
           <a:prstGeom prst="rect">
@@ -7439,7 +7293,7 @@
         </p:blipFill>
         <p:spPr>
           <a:xfrm>
-            <a:off x="457200" y="1280160"/>
+            <a:off x="457200" y="1234440"/>
             <a:ext cx="3977640" cy="2237423"/>
           </a:xfrm>
           <a:prstGeom prst="rect">
@@ -7455,7 +7309,7 @@
         </p:nvSpPr>
         <p:spPr>
           <a:xfrm>
-            <a:off x="4690872" y="1261872"/>
+            <a:off x="4690872" y="1216152"/>
             <a:ext cx="4014216" cy="2273999"/>
           </a:xfrm>
           <a:prstGeom prst="rect">
@@ -7495,7 +7349,7 @@
         </p:blipFill>
         <p:spPr>
           <a:xfrm>
-            <a:off x="4709160" y="1280160"/>
+            <a:off x="4709160" y="1234440"/>
             <a:ext cx="3977640" cy="2237423"/>
           </a:xfrm>
           <a:prstGeom prst="rect">
@@ -7511,20 +7365,23 @@
         </p:nvSpPr>
         <p:spPr>
           <a:xfrm>
-            <a:off x="457200" y="3611880"/>
-            <a:ext cx="3977640" cy="274320"/>
-          </a:xfrm>
-          <a:prstGeom prst="rect">
-            <a:avLst/>
-          </a:prstGeom>
-          <a:noFill/>
-          <a:ln/>
-        </p:spPr>
-        <p:txBody>
-          <a:bodyPr wrap="square" lIns="0" tIns="0" rIns="0" bIns="0" rtlCol="0" anchor="ctr"/>
-          <a:lstStyle/>
-          <a:p>
-            <a:pPr indent="0" marL="0">
+            <a:off x="457200" y="3746183"/>
+            <a:ext cx="3977640" cy="1097280"/>
+          </a:xfrm>
+          <a:prstGeom prst="rect">
+            <a:avLst/>
+          </a:prstGeom>
+          <a:noFill/>
+          <a:ln/>
+        </p:spPr>
+        <p:txBody>
+          <a:bodyPr wrap="square" lIns="0" tIns="0" rIns="0" bIns="0" rtlCol="0" anchor="t"/>
+          <a:lstStyle/>
+          <a:p>
+            <a:pPr indent="0" marL="0">
+              <a:spcAft>
+                <a:spcPts val="300"/>
+              </a:spcAft>
               <a:buNone/>
             </a:pPr>
             <a:r>
@@ -7540,6 +7397,23 @@
             </a:r>
             <a:endParaRPr lang="en-US" sz="1300" dirty="0"/>
           </a:p>
+          <a:p>
+            <a:pPr indent="0" marL="0">
+              <a:buNone/>
+            </a:pPr>
+            <a:r>
+              <a:rPr lang="en-US" sz="1200" dirty="0">
+                <a:solidFill>
+                  <a:srgbClr val="DBE3EA"/>
+                </a:solidFill>
+                <a:latin typeface="Calibri" pitchFamily="34" charset="0"/>
+                <a:ea typeface="Calibri" pitchFamily="34" charset="-122"/>
+                <a:cs typeface="Calibri" pitchFamily="34" charset="-120"/>
+              </a:rPr>
+              <a:t>Spread, commission, slippage, overnight financing — high-turnover mein zyada asar</a:t>
+            </a:r>
+            <a:endParaRPr lang="en-US" sz="1300" dirty="0"/>
+          </a:p>
         </p:txBody>
       </p:sp>
       <p:sp>
@@ -7550,8 +7424,8 @@
         </p:nvSpPr>
         <p:spPr>
           <a:xfrm>
-            <a:off x="457200" y="3904488"/>
-            <a:ext cx="3977640" cy="502920"/>
+            <a:off x="4709160" y="3746183"/>
+            <a:ext cx="3977640" cy="1097280"/>
           </a:xfrm>
           <a:prstGeom prst="rect">
             <a:avLst/>
@@ -7564,6 +7438,26 @@
           <a:lstStyle/>
           <a:p>
             <a:pPr indent="0" marL="0">
+              <a:spcAft>
+                <a:spcPts val="300"/>
+              </a:spcAft>
+              <a:buNone/>
+            </a:pPr>
+            <a:r>
+              <a:rPr lang="en-US" sz="1300" b="1" dirty="0">
+                <a:solidFill>
+                  <a:srgbClr val="C8FF4D"/>
+                </a:solidFill>
+                <a:latin typeface="Calibri" pitchFamily="34" charset="0"/>
+                <a:ea typeface="Calibri" pitchFamily="34" charset="-122"/>
+                <a:cs typeface="Calibri" pitchFamily="34" charset="-120"/>
+              </a:rPr>
+              <a:t>Capacity &amp; signal degradation</a:t>
+            </a:r>
+            <a:endParaRPr lang="en-US" sz="1300" dirty="0"/>
+          </a:p>
+          <a:p>
+            <a:pPr indent="0" marL="0">
               <a:buNone/>
             </a:pPr>
             <a:r>
@@ -7575,87 +7469,9 @@
                 <a:ea typeface="Calibri" pitchFamily="34" charset="-122"/>
                 <a:cs typeface="Calibri" pitchFamily="34" charset="-120"/>
               </a:rPr>
-              <a:t>Spread, commission, slippage, overnight financing — high-turnover mein zyada asar</a:t>
-            </a:r>
-            <a:endParaRPr lang="en-US" sz="1200" dirty="0"/>
-          </a:p>
-        </p:txBody>
-      </p:sp>
-      <p:sp>
-        <p:nvSpPr>
-          <p:cNvPr id="11" name="Text 7"/>
-          <p:cNvSpPr txBox="1"/>
-          <p:nvPr/>
-        </p:nvSpPr>
-        <p:spPr>
-          <a:xfrm>
-            <a:off x="4709160" y="3611880"/>
-            <a:ext cx="3977640" cy="274320"/>
-          </a:xfrm>
-          <a:prstGeom prst="rect">
-            <a:avLst/>
-          </a:prstGeom>
-          <a:noFill/>
-          <a:ln/>
-        </p:spPr>
-        <p:txBody>
-          <a:bodyPr wrap="square" lIns="0" tIns="0" rIns="0" bIns="0" rtlCol="0" anchor="ctr"/>
-          <a:lstStyle/>
-          <a:p>
-            <a:pPr indent="0" marL="0">
-              <a:buNone/>
-            </a:pPr>
-            <a:r>
-              <a:rPr lang="en-US" sz="1300" b="1" dirty="0">
-                <a:solidFill>
-                  <a:srgbClr val="C8FF4D"/>
-                </a:solidFill>
-                <a:latin typeface="Calibri" pitchFamily="34" charset="0"/>
-                <a:ea typeface="Calibri" pitchFamily="34" charset="-122"/>
-                <a:cs typeface="Calibri" pitchFamily="34" charset="-120"/>
-              </a:rPr>
-              <a:t>Capacity &amp; signal degradation</a:t>
+              <a:t>Zyada capital market move karta hai; zyada traders use karein to pattern kam effective</a:t>
             </a:r>
             <a:endParaRPr lang="en-US" sz="1300" dirty="0"/>
-          </a:p>
-        </p:txBody>
-      </p:sp>
-      <p:sp>
-        <p:nvSpPr>
-          <p:cNvPr id="12" name="Text 8"/>
-          <p:cNvSpPr txBox="1"/>
-          <p:nvPr/>
-        </p:nvSpPr>
-        <p:spPr>
-          <a:xfrm>
-            <a:off x="4709160" y="3904488"/>
-            <a:ext cx="3977640" cy="502920"/>
-          </a:xfrm>
-          <a:prstGeom prst="rect">
-            <a:avLst/>
-          </a:prstGeom>
-          <a:noFill/>
-          <a:ln/>
-        </p:spPr>
-        <p:txBody>
-          <a:bodyPr wrap="square" lIns="0" tIns="0" rIns="0" bIns="0" rtlCol="0" anchor="t"/>
-          <a:lstStyle/>
-          <a:p>
-            <a:pPr indent="0" marL="0">
-              <a:buNone/>
-            </a:pPr>
-            <a:r>
-              <a:rPr lang="en-US" sz="1200" dirty="0">
-                <a:solidFill>
-                  <a:srgbClr val="DBE3EA"/>
-                </a:solidFill>
-                <a:latin typeface="Calibri" pitchFamily="34" charset="0"/>
-                <a:ea typeface="Calibri" pitchFamily="34" charset="-122"/>
-                <a:cs typeface="Calibri" pitchFamily="34" charset="-120"/>
-              </a:rPr>
-              <a:t>Zyada capital market move karta hai; zyada traders use karein to pattern kam effective</a:t>
-            </a:r>
-            <a:endParaRPr lang="en-US" sz="1200" dirty="0"/>
           </a:p>
         </p:txBody>
       </p:sp>
@@ -7738,8 +7554,8 @@
         </p:nvSpPr>
         <p:spPr>
           <a:xfrm>
-            <a:off x="457200" y="548640"/>
-            <a:ext cx="8229600" cy="594360"/>
+            <a:off x="457200" y="566928"/>
+            <a:ext cx="8229600" cy="548640"/>
           </a:xfrm>
           <a:prstGeom prst="rect">
             <a:avLst/>
@@ -7755,7 +7571,7 @@
               <a:buNone/>
             </a:pPr>
             <a:r>
-              <a:rPr lang="en-US" sz="2800" dirty="0">
+              <a:rPr lang="en-US" sz="2400" dirty="0">
                 <a:solidFill>
                   <a:srgbClr val="DBE3EA"/>
                 </a:solidFill>
@@ -7765,7 +7581,7 @@
               </a:rPr>
               <a:t>Ek number jo sab kuch shuru karta hai</a:t>
             </a:r>
-            <a:endParaRPr lang="en-US" sz="2800" dirty="0"/>
+            <a:endParaRPr lang="en-US" sz="2400" dirty="0"/>
           </a:p>
         </p:txBody>
       </p:sp>
@@ -7855,20 +7671,23 @@
         </p:nvSpPr>
         <p:spPr>
           <a:xfrm>
-            <a:off x="457200" y="2651760"/>
-            <a:ext cx="3931920" cy="320040"/>
-          </a:xfrm>
-          <a:prstGeom prst="rect">
-            <a:avLst/>
-          </a:prstGeom>
-          <a:noFill/>
-          <a:ln/>
-        </p:spPr>
-        <p:txBody>
-          <a:bodyPr wrap="square" lIns="0" tIns="0" rIns="0" bIns="0" rtlCol="0" anchor="ctr"/>
-          <a:lstStyle/>
-          <a:p>
-            <a:pPr indent="0" marL="0">
+            <a:off x="457200" y="2606040"/>
+            <a:ext cx="3749040" cy="822960"/>
+          </a:xfrm>
+          <a:prstGeom prst="rect">
+            <a:avLst/>
+          </a:prstGeom>
+          <a:noFill/>
+          <a:ln/>
+        </p:spPr>
+        <p:txBody>
+          <a:bodyPr wrap="square" lIns="0" tIns="0" rIns="0" bIns="0" rtlCol="0" anchor="t"/>
+          <a:lstStyle/>
+          <a:p>
+            <a:pPr indent="0" marL="0">
+              <a:spcAft>
+                <a:spcPts val="300"/>
+              </a:spcAft>
               <a:buNone/>
             </a:pPr>
             <a:r>
@@ -7884,6 +7703,23 @@
             </a:r>
             <a:endParaRPr lang="en-US" sz="1300" dirty="0"/>
           </a:p>
+          <a:p>
+            <a:pPr indent="0" marL="0">
+              <a:buNone/>
+            </a:pPr>
+            <a:r>
+              <a:rPr lang="en-US" sz="1300" dirty="0">
+                <a:solidFill>
+                  <a:srgbClr val="8A97A4"/>
+                </a:solidFill>
+                <a:latin typeface="Calibri" pitchFamily="34" charset="0"/>
+                <a:ea typeface="Calibri" pitchFamily="34" charset="-122"/>
+                <a:cs typeface="Calibri" pitchFamily="34" charset="-120"/>
+              </a:rPr>
+              <a:t>Medallion Fund — 30+ saal tak</a:t>
+            </a:r>
+            <a:endParaRPr lang="en-US" sz="1300" dirty="0"/>
+          </a:p>
         </p:txBody>
       </p:sp>
       <p:sp>
@@ -7894,47 +7730,8 @@
         </p:nvSpPr>
         <p:spPr>
           <a:xfrm>
-            <a:off x="457200" y="2971800"/>
-            <a:ext cx="3931920" cy="320040"/>
-          </a:xfrm>
-          <a:prstGeom prst="rect">
-            <a:avLst/>
-          </a:prstGeom>
-          <a:noFill/>
-          <a:ln/>
-        </p:spPr>
-        <p:txBody>
-          <a:bodyPr wrap="square" lIns="0" tIns="0" rIns="0" bIns="0" rtlCol="0" anchor="ctr"/>
-          <a:lstStyle/>
-          <a:p>
-            <a:pPr indent="0" marL="0">
-              <a:buNone/>
-            </a:pPr>
-            <a:r>
-              <a:rPr lang="en-US" sz="1300" dirty="0">
-                <a:solidFill>
-                  <a:srgbClr val="8A97A4"/>
-                </a:solidFill>
-                <a:latin typeface="Calibri" pitchFamily="34" charset="0"/>
-                <a:ea typeface="Calibri" pitchFamily="34" charset="-122"/>
-                <a:cs typeface="Calibri" pitchFamily="34" charset="-120"/>
-              </a:rPr>
-              <a:t>Medallion Fund — 30+ saal tak</a:t>
-            </a:r>
-            <a:endParaRPr lang="en-US" sz="1300" dirty="0"/>
-          </a:p>
-        </p:txBody>
-      </p:sp>
-      <p:sp>
-        <p:nvSpPr>
-          <p:cNvPr id="8" name="Text 6"/>
-          <p:cNvSpPr txBox="1"/>
-          <p:nvPr/>
-        </p:nvSpPr>
-        <p:spPr>
-          <a:xfrm>
-            <a:off x="457200" y="3520440"/>
-            <a:ext cx="3749040" cy="731520"/>
+            <a:off x="457200" y="3611880"/>
+            <a:ext cx="3749040" cy="822960"/>
           </a:xfrm>
           <a:prstGeom prst="rect">
             <a:avLst/>
@@ -7966,7 +7763,7 @@
       </p:sp>
       <p:sp>
         <p:nvSpPr>
-          <p:cNvPr id="9" name="Shape 7"/>
+          <p:cNvPr id="8" name="Shape 6"/>
           <p:cNvSpPr/>
           <p:nvPr/>
         </p:nvSpPr>
@@ -7998,7 +7795,7 @@
       </p:sp>
       <p:pic>
         <p:nvPicPr>
-          <p:cNvPr id="10" name="Image 0" descr="Video frame, scene S02">    </p:cNvPr>
+          <p:cNvPr id="9" name="Image 0" descr="Video frame, scene S02">    </p:cNvPr>
           <p:cNvPicPr>
             <a:picLocks noChangeAspect="1"/>
           </p:cNvPicPr>
@@ -8022,23 +7819,23 @@
       </p:pic>
       <p:sp>
         <p:nvSpPr>
-          <p:cNvPr id="11" name="Text 8"/>
-          <p:cNvSpPr txBox="1"/>
-          <p:nvPr/>
-        </p:nvSpPr>
-        <p:spPr>
-          <a:xfrm>
-            <a:off x="4526280" y="3840480"/>
-            <a:ext cx="4114800" cy="256032"/>
-          </a:xfrm>
-          <a:prstGeom prst="rect">
-            <a:avLst/>
-          </a:prstGeom>
-          <a:noFill/>
-          <a:ln/>
-        </p:spPr>
-        <p:txBody>
-          <a:bodyPr wrap="square" lIns="0" tIns="0" rIns="0" bIns="0" rtlCol="0" anchor="ctr"/>
+          <p:cNvPr id="10" name="Text 7"/>
+          <p:cNvSpPr txBox="1"/>
+          <p:nvPr/>
+        </p:nvSpPr>
+        <p:spPr>
+          <a:xfrm>
+            <a:off x="4526280" y="4031933"/>
+            <a:ext cx="4160520" cy="274320"/>
+          </a:xfrm>
+          <a:prstGeom prst="rect">
+            <a:avLst/>
+          </a:prstGeom>
+          <a:noFill/>
+          <a:ln/>
+        </p:spPr>
+        <p:txBody>
+          <a:bodyPr wrap="square" lIns="0" tIns="0" rIns="0" bIns="0" rtlCol="0" anchor="t"/>
           <a:lstStyle/>
           <a:p>
             <a:pPr indent="0" marL="0">
@@ -8138,8 +7935,8 @@
         </p:nvSpPr>
         <p:spPr>
           <a:xfrm>
-            <a:off x="457200" y="548640"/>
-            <a:ext cx="8229600" cy="594360"/>
+            <a:off x="457200" y="566928"/>
+            <a:ext cx="8229600" cy="548640"/>
           </a:xfrm>
           <a:prstGeom prst="rect">
             <a:avLst/>
@@ -8155,7 +7952,7 @@
               <a:buNone/>
             </a:pPr>
             <a:r>
-              <a:rPr lang="en-US" sz="2800" dirty="0">
+              <a:rPr lang="en-US" sz="2400" dirty="0">
                 <a:solidFill>
                   <a:srgbClr val="DBE3EA"/>
                 </a:solidFill>
@@ -8165,7 +7962,7 @@
               </a:rPr>
               <a:t>Paanch common mistakes</a:t>
             </a:r>
-            <a:endParaRPr lang="en-US" sz="2800" dirty="0"/>
+            <a:endParaRPr lang="en-US" sz="2400" dirty="0"/>
           </a:p>
         </p:txBody>
       </p:sp>
@@ -9085,8 +8882,8 @@
         </p:nvSpPr>
         <p:spPr>
           <a:xfrm>
-            <a:off x="457200" y="548640"/>
-            <a:ext cx="8229600" cy="594360"/>
+            <a:off x="457200" y="566928"/>
+            <a:ext cx="8229600" cy="548640"/>
           </a:xfrm>
           <a:prstGeom prst="rect">
             <a:avLst/>
@@ -9102,7 +8899,7 @@
               <a:buNone/>
             </a:pPr>
             <a:r>
-              <a:rPr lang="en-US" sz="2800" dirty="0">
+              <a:rPr lang="en-US" sz="2400" dirty="0">
                 <a:solidFill>
                   <a:srgbClr val="DBE3EA"/>
                 </a:solidFill>
@@ -9112,7 +8909,7 @@
               </a:rPr>
               <a:t>Sirf educational purpose ke liye</a:t>
             </a:r>
-            <a:endParaRPr lang="en-US" sz="2800" dirty="0"/>
+            <a:endParaRPr lang="en-US" sz="2400" dirty="0"/>
           </a:p>
         </p:txBody>
       </p:sp>
@@ -9441,8 +9238,8 @@
         </p:nvSpPr>
         <p:spPr>
           <a:xfrm>
-            <a:off x="457200" y="548640"/>
-            <a:ext cx="8229600" cy="594360"/>
+            <a:off x="457200" y="566928"/>
+            <a:ext cx="8229600" cy="548640"/>
           </a:xfrm>
           <a:prstGeom prst="rect">
             <a:avLst/>
@@ -9458,7 +9255,7 @@
               <a:buNone/>
             </a:pPr>
             <a:r>
-              <a:rPr lang="en-US" sz="2800" dirty="0">
+              <a:rPr lang="en-US" sz="2400" dirty="0">
                 <a:solidFill>
                   <a:srgbClr val="DBE3EA"/>
                 </a:solidFill>
@@ -9468,7 +9265,7 @@
               </a:rPr>
               <a:t>Hum kya samjhenge — aur kya nahi</a:t>
             </a:r>
-            <a:endParaRPr lang="en-US" sz="2800" dirty="0"/>
+            <a:endParaRPr lang="en-US" sz="2400" dirty="0"/>
           </a:p>
         </p:txBody>
       </p:sp>
@@ -9583,20 +9380,23 @@
         </p:nvSpPr>
         <p:spPr>
           <a:xfrm>
-            <a:off x="1051560" y="1399032"/>
-            <a:ext cx="6858000" cy="274320"/>
-          </a:xfrm>
-          <a:prstGeom prst="rect">
-            <a:avLst/>
-          </a:prstGeom>
-          <a:noFill/>
-          <a:ln/>
-        </p:spPr>
-        <p:txBody>
-          <a:bodyPr wrap="square" lIns="0" tIns="0" rIns="0" bIns="0" rtlCol="0" anchor="ctr"/>
-          <a:lstStyle/>
-          <a:p>
-            <a:pPr indent="0" marL="0">
+            <a:off x="1051560" y="1380744"/>
+            <a:ext cx="7589520" cy="713232"/>
+          </a:xfrm>
+          <a:prstGeom prst="rect">
+            <a:avLst/>
+          </a:prstGeom>
+          <a:noFill/>
+          <a:ln/>
+        </p:spPr>
+        <p:txBody>
+          <a:bodyPr wrap="square" lIns="0" tIns="0" rIns="0" bIns="0" rtlCol="0" anchor="t"/>
+          <a:lstStyle/>
+          <a:p>
+            <a:pPr indent="0" marL="0">
+              <a:spcAft>
+                <a:spcPts val="300"/>
+              </a:spcAft>
               <a:buNone/>
             </a:pPr>
             <a:r>
@@ -9612,28 +9412,6 @@
             </a:r>
             <a:endParaRPr lang="en-US" sz="1600" dirty="0"/>
           </a:p>
-        </p:txBody>
-      </p:sp>
-      <p:sp>
-        <p:nvSpPr>
-          <p:cNvPr id="8" name="Text 6"/>
-          <p:cNvSpPr txBox="1"/>
-          <p:nvPr/>
-        </p:nvSpPr>
-        <p:spPr>
-          <a:xfrm>
-            <a:off x="1051560" y="1673352"/>
-            <a:ext cx="6858000" cy="274320"/>
-          </a:xfrm>
-          <a:prstGeom prst="rect">
-            <a:avLst/>
-          </a:prstGeom>
-          <a:noFill/>
-          <a:ln/>
-        </p:spPr>
-        <p:txBody>
-          <a:bodyPr wrap="square" lIns="0" tIns="0" rIns="0" bIns="0" rtlCol="0" anchor="ctr"/>
-          <a:lstStyle/>
           <a:p>
             <a:pPr indent="0" marL="0">
               <a:buNone/>
@@ -9649,13 +9427,13 @@
               </a:rPr>
               <a:t>Simons ne markets ko kaise approach kiya</a:t>
             </a:r>
-            <a:endParaRPr lang="en-US" sz="1300" dirty="0"/>
-          </a:p>
-        </p:txBody>
-      </p:sp>
-      <p:sp>
-        <p:nvSpPr>
-          <p:cNvPr id="9" name="Shape 7"/>
+            <a:endParaRPr lang="en-US" sz="1600" dirty="0"/>
+          </a:p>
+        </p:txBody>
+      </p:sp>
+      <p:sp>
+        <p:nvSpPr>
+          <p:cNvPr id="8" name="Shape 6"/>
           <p:cNvSpPr/>
           <p:nvPr/>
         </p:nvSpPr>
@@ -9680,7 +9458,7 @@
       </p:sp>
       <p:sp>
         <p:nvSpPr>
-          <p:cNvPr id="10" name="Text 8"/>
+          <p:cNvPr id="9" name="Text 7"/>
           <p:cNvSpPr txBox="1"/>
           <p:nvPr/>
         </p:nvSpPr>
@@ -9719,26 +9497,29 @@
       </p:sp>
       <p:sp>
         <p:nvSpPr>
-          <p:cNvPr id="11" name="Text 9"/>
-          <p:cNvSpPr txBox="1"/>
-          <p:nvPr/>
-        </p:nvSpPr>
-        <p:spPr>
-          <a:xfrm>
-            <a:off x="1051560" y="2176272"/>
-            <a:ext cx="6858000" cy="274320"/>
-          </a:xfrm>
-          <a:prstGeom prst="rect">
-            <a:avLst/>
-          </a:prstGeom>
-          <a:noFill/>
-          <a:ln/>
-        </p:spPr>
-        <p:txBody>
-          <a:bodyPr wrap="square" lIns="0" tIns="0" rIns="0" bIns="0" rtlCol="0" anchor="ctr"/>
-          <a:lstStyle/>
-          <a:p>
-            <a:pPr indent="0" marL="0">
+          <p:cNvPr id="10" name="Text 8"/>
+          <p:cNvSpPr txBox="1"/>
+          <p:nvPr/>
+        </p:nvSpPr>
+        <p:spPr>
+          <a:xfrm>
+            <a:off x="1051560" y="2157984"/>
+            <a:ext cx="7589520" cy="713232"/>
+          </a:xfrm>
+          <a:prstGeom prst="rect">
+            <a:avLst/>
+          </a:prstGeom>
+          <a:noFill/>
+          <a:ln/>
+        </p:spPr>
+        <p:txBody>
+          <a:bodyPr wrap="square" lIns="0" tIns="0" rIns="0" bIns="0" rtlCol="0" anchor="t"/>
+          <a:lstStyle/>
+          <a:p>
+            <a:pPr indent="0" marL="0">
+              <a:spcAft>
+                <a:spcPts val="300"/>
+              </a:spcAft>
               <a:buNone/>
             </a:pPr>
             <a:r>
@@ -9754,28 +9535,6 @@
             </a:r>
             <a:endParaRPr lang="en-US" sz="1600" dirty="0"/>
           </a:p>
-        </p:txBody>
-      </p:sp>
-      <p:sp>
-        <p:nvSpPr>
-          <p:cNvPr id="12" name="Text 10"/>
-          <p:cNvSpPr txBox="1"/>
-          <p:nvPr/>
-        </p:nvSpPr>
-        <p:spPr>
-          <a:xfrm>
-            <a:off x="1051560" y="2450592"/>
-            <a:ext cx="6858000" cy="274320"/>
-          </a:xfrm>
-          <a:prstGeom prst="rect">
-            <a:avLst/>
-          </a:prstGeom>
-          <a:noFill/>
-          <a:ln/>
-        </p:spPr>
-        <p:txBody>
-          <a:bodyPr wrap="square" lIns="0" tIns="0" rIns="0" bIns="0" rtlCol="0" anchor="ctr"/>
-          <a:lstStyle/>
           <a:p>
             <a:pPr indent="0" marL="0">
               <a:buNone/>
@@ -9791,13 +9550,13 @@
               </a:rPr>
               <a:t>Unki edge ke peeche asli wajah kya thi</a:t>
             </a:r>
-            <a:endParaRPr lang="en-US" sz="1300" dirty="0"/>
-          </a:p>
-        </p:txBody>
-      </p:sp>
-      <p:sp>
-        <p:nvSpPr>
-          <p:cNvPr id="13" name="Shape 11"/>
+            <a:endParaRPr lang="en-US" sz="1600" dirty="0"/>
+          </a:p>
+        </p:txBody>
+      </p:sp>
+      <p:sp>
+        <p:nvSpPr>
+          <p:cNvPr id="11" name="Shape 9"/>
           <p:cNvSpPr/>
           <p:nvPr/>
         </p:nvSpPr>
@@ -9822,7 +9581,7 @@
       </p:sp>
       <p:sp>
         <p:nvSpPr>
-          <p:cNvPr id="14" name="Text 12"/>
+          <p:cNvPr id="12" name="Text 10"/>
           <p:cNvSpPr txBox="1"/>
           <p:nvPr/>
         </p:nvSpPr>
@@ -9861,26 +9620,29 @@
       </p:sp>
       <p:sp>
         <p:nvSpPr>
-          <p:cNvPr id="15" name="Text 13"/>
-          <p:cNvSpPr txBox="1"/>
-          <p:nvPr/>
-        </p:nvSpPr>
-        <p:spPr>
-          <a:xfrm>
-            <a:off x="1051560" y="2953512"/>
-            <a:ext cx="6858000" cy="274320"/>
-          </a:xfrm>
-          <a:prstGeom prst="rect">
-            <a:avLst/>
-          </a:prstGeom>
-          <a:noFill/>
-          <a:ln/>
-        </p:spPr>
-        <p:txBody>
-          <a:bodyPr wrap="square" lIns="0" tIns="0" rIns="0" bIns="0" rtlCol="0" anchor="ctr"/>
-          <a:lstStyle/>
-          <a:p>
-            <a:pPr indent="0" marL="0">
+          <p:cNvPr id="13" name="Text 11"/>
+          <p:cNvSpPr txBox="1"/>
+          <p:nvPr/>
+        </p:nvSpPr>
+        <p:spPr>
+          <a:xfrm>
+            <a:off x="1051560" y="2935224"/>
+            <a:ext cx="7589520" cy="713232"/>
+          </a:xfrm>
+          <a:prstGeom prst="rect">
+            <a:avLst/>
+          </a:prstGeom>
+          <a:noFill/>
+          <a:ln/>
+        </p:spPr>
+        <p:txBody>
+          <a:bodyPr wrap="square" lIns="0" tIns="0" rIns="0" bIns="0" rtlCol="0" anchor="t"/>
+          <a:lstStyle/>
+          <a:p>
+            <a:pPr indent="0" marL="0">
+              <a:spcAft>
+                <a:spcPts val="300"/>
+              </a:spcAft>
               <a:buNone/>
             </a:pPr>
             <a:r>
@@ -9896,28 +9658,6 @@
             </a:r>
             <a:endParaRPr lang="en-US" sz="1600" dirty="0"/>
           </a:p>
-        </p:txBody>
-      </p:sp>
-      <p:sp>
-        <p:nvSpPr>
-          <p:cNvPr id="16" name="Text 14"/>
-          <p:cNvSpPr txBox="1"/>
-          <p:nvPr/>
-        </p:nvSpPr>
-        <p:spPr>
-          <a:xfrm>
-            <a:off x="1051560" y="3227832"/>
-            <a:ext cx="6858000" cy="274320"/>
-          </a:xfrm>
-          <a:prstGeom prst="rect">
-            <a:avLst/>
-          </a:prstGeom>
-          <a:noFill/>
-          <a:ln/>
-        </p:spPr>
-        <p:txBody>
-          <a:bodyPr wrap="square" lIns="0" tIns="0" rIns="0" bIns="0" rtlCol="0" anchor="ctr"/>
-          <a:lstStyle/>
           <a:p>
             <a:pPr indent="0" marL="0">
               <a:buNone/>
@@ -9933,13 +9673,13 @@
               </a:rPr>
               <a:t>Kaunse principles ek retail trader realistically use kar sakta hai</a:t>
             </a:r>
-            <a:endParaRPr lang="en-US" sz="1300" dirty="0"/>
-          </a:p>
-        </p:txBody>
-      </p:sp>
-      <p:sp>
-        <p:nvSpPr>
-          <p:cNvPr id="17" name="Shape 15"/>
+            <a:endParaRPr lang="en-US" sz="1600" dirty="0"/>
+          </a:p>
+        </p:txBody>
+      </p:sp>
+      <p:sp>
+        <p:nvSpPr>
+          <p:cNvPr id="14" name="Shape 12"/>
           <p:cNvSpPr/>
           <p:nvPr/>
         </p:nvSpPr>
@@ -9964,7 +9704,7 @@
       </p:sp>
       <p:sp>
         <p:nvSpPr>
-          <p:cNvPr id="18" name="Text 16"/>
+          <p:cNvPr id="15" name="Text 13"/>
           <p:cNvSpPr txBox="1"/>
           <p:nvPr/>
         </p:nvSpPr>
@@ -10003,26 +9743,29 @@
       </p:sp>
       <p:sp>
         <p:nvSpPr>
-          <p:cNvPr id="19" name="Text 17"/>
-          <p:cNvSpPr txBox="1"/>
-          <p:nvPr/>
-        </p:nvSpPr>
-        <p:spPr>
-          <a:xfrm>
-            <a:off x="1051560" y="3730752"/>
-            <a:ext cx="6858000" cy="274320"/>
-          </a:xfrm>
-          <a:prstGeom prst="rect">
-            <a:avLst/>
-          </a:prstGeom>
-          <a:noFill/>
-          <a:ln/>
-        </p:spPr>
-        <p:txBody>
-          <a:bodyPr wrap="square" lIns="0" tIns="0" rIns="0" bIns="0" rtlCol="0" anchor="ctr"/>
-          <a:lstStyle/>
-          <a:p>
-            <a:pPr indent="0" marL="0">
+          <p:cNvPr id="16" name="Text 14"/>
+          <p:cNvSpPr txBox="1"/>
+          <p:nvPr/>
+        </p:nvSpPr>
+        <p:spPr>
+          <a:xfrm>
+            <a:off x="1051560" y="3712464"/>
+            <a:ext cx="7589520" cy="713232"/>
+          </a:xfrm>
+          <a:prstGeom prst="rect">
+            <a:avLst/>
+          </a:prstGeom>
+          <a:noFill/>
+          <a:ln/>
+        </p:spPr>
+        <p:txBody>
+          <a:bodyPr wrap="square" lIns="0" tIns="0" rIns="0" bIns="0" rtlCol="0" anchor="t"/>
+          <a:lstStyle/>
+          <a:p>
+            <a:pPr indent="0" marL="0">
+              <a:spcAft>
+                <a:spcPts val="300"/>
+              </a:spcAft>
               <a:buNone/>
             </a:pPr>
             <a:r>
@@ -10038,28 +9781,6 @@
             </a:r>
             <a:endParaRPr lang="en-US" sz="1600" dirty="0"/>
           </a:p>
-        </p:txBody>
-      </p:sp>
-      <p:sp>
-        <p:nvSpPr>
-          <p:cNvPr id="20" name="Text 18"/>
-          <p:cNvSpPr txBox="1"/>
-          <p:nvPr/>
-        </p:nvSpPr>
-        <p:spPr>
-          <a:xfrm>
-            <a:off x="1051560" y="4005072"/>
-            <a:ext cx="6858000" cy="274320"/>
-          </a:xfrm>
-          <a:prstGeom prst="rect">
-            <a:avLst/>
-          </a:prstGeom>
-          <a:noFill/>
-          <a:ln/>
-        </p:spPr>
-        <p:txBody>
-          <a:bodyPr wrap="square" lIns="0" tIns="0" rIns="0" bIns="0" rtlCol="0" anchor="ctr"/>
-          <a:lstStyle/>
           <a:p>
             <a:pPr indent="0" marL="0">
               <a:buNone/>
@@ -10075,7 +9796,7 @@
               </a:rPr>
               <a:t>Kya copy karna possible hi nahi hai</a:t>
             </a:r>
-            <a:endParaRPr lang="en-US" sz="1300" dirty="0"/>
+            <a:endParaRPr lang="en-US" sz="1600" dirty="0"/>
           </a:p>
         </p:txBody>
       </p:sp>
@@ -10158,8 +9879,8 @@
         </p:nvSpPr>
         <p:spPr>
           <a:xfrm>
-            <a:off x="457200" y="548640"/>
-            <a:ext cx="8229600" cy="594360"/>
+            <a:off x="457200" y="566928"/>
+            <a:ext cx="8229600" cy="548640"/>
           </a:xfrm>
           <a:prstGeom prst="rect">
             <a:avLst/>
@@ -10175,7 +9896,7 @@
               <a:buNone/>
             </a:pPr>
             <a:r>
-              <a:rPr lang="en-US" sz="2800" dirty="0">
+              <a:rPr lang="en-US" sz="2400" dirty="0">
                 <a:solidFill>
                   <a:srgbClr val="DBE3EA"/>
                 </a:solidFill>
@@ -10185,7 +9906,7 @@
               </a:rPr>
               <a:t>1982: Renaissance Technologies</a:t>
             </a:r>
-            <a:endParaRPr lang="en-US" sz="2800" dirty="0"/>
+            <a:endParaRPr lang="en-US" sz="2400" dirty="0"/>
           </a:p>
         </p:txBody>
       </p:sp>
@@ -10275,8 +9996,8 @@
         </p:nvSpPr>
         <p:spPr>
           <a:xfrm>
-            <a:off x="457200" y="2423160"/>
-            <a:ext cx="4023360" cy="2011680"/>
+            <a:off x="457200" y="2377440"/>
+            <a:ext cx="4572000" cy="2286000"/>
           </a:xfrm>
           <a:prstGeom prst="rect">
             <a:avLst/>
@@ -10408,8 +10129,8 @@
         </p:nvSpPr>
         <p:spPr>
           <a:xfrm>
-            <a:off x="5413248" y="1207008"/>
-            <a:ext cx="3072384" cy="3072384"/>
+            <a:off x="5413248" y="1252728"/>
+            <a:ext cx="2798064" cy="2798064"/>
           </a:xfrm>
           <a:prstGeom prst="rect">
             <a:avLst/>
@@ -10448,8 +10169,8 @@
         </p:blipFill>
         <p:spPr>
           <a:xfrm>
-            <a:off x="5440680" y="1234440"/>
-            <a:ext cx="3017520" cy="3017520"/>
+            <a:off x="5440680" y="1280160"/>
+            <a:ext cx="2743200" cy="2743200"/>
           </a:xfrm>
           <a:prstGeom prst="rect">
             <a:avLst/>
@@ -10464,57 +10185,38 @@
         </p:nvSpPr>
         <p:spPr>
           <a:xfrm>
-            <a:off x="5440680" y="4361688"/>
-            <a:ext cx="3017520" cy="274320"/>
-          </a:xfrm>
-          <a:prstGeom prst="rect">
-            <a:avLst/>
-          </a:prstGeom>
-          <a:noFill/>
-          <a:ln/>
-        </p:spPr>
-        <p:txBody>
-          <a:bodyPr wrap="square" lIns="0" tIns="0" rIns="0" bIns="0" rtlCol="0" anchor="ctr"/>
-          <a:lstStyle/>
-          <a:p>
-            <a:pPr indent="0" marL="0">
-              <a:buNone/>
-            </a:pPr>
-            <a:r>
-              <a:rPr lang="en-US" sz="1400" dirty="0">
+            <a:off x="5440680" y="4297680"/>
+            <a:ext cx="2743200" cy="502920"/>
+          </a:xfrm>
+          <a:prstGeom prst="rect">
+            <a:avLst/>
+          </a:prstGeom>
+          <a:noFill/>
+          <a:ln/>
+        </p:spPr>
+        <p:txBody>
+          <a:bodyPr wrap="square" lIns="0" tIns="0" rIns="0" bIns="0" rtlCol="0" anchor="t"/>
+          <a:lstStyle/>
+          <a:p>
+            <a:pPr indent="0" marL="0">
+              <a:spcAft>
+                <a:spcPts val="300"/>
+              </a:spcAft>
+              <a:buNone/>
+            </a:pPr>
+            <a:r>
+              <a:rPr lang="en-US" sz="1400" b="1" dirty="0">
                 <a:solidFill>
                   <a:srgbClr val="DBE3EA"/>
                 </a:solidFill>
-                <a:latin typeface="Cambria" pitchFamily="34" charset="0"/>
-                <a:ea typeface="Cambria" pitchFamily="34" charset="-122"/>
-                <a:cs typeface="Cambria" pitchFamily="34" charset="-120"/>
+                <a:latin typeface="Calibri" pitchFamily="34" charset="0"/>
+                <a:ea typeface="Calibri" pitchFamily="34" charset="-122"/>
+                <a:cs typeface="Calibri" pitchFamily="34" charset="-120"/>
               </a:rPr>
               <a:t>Jim Simons</a:t>
             </a:r>
             <a:endParaRPr lang="en-US" sz="1400" dirty="0"/>
           </a:p>
-        </p:txBody>
-      </p:sp>
-      <p:sp>
-        <p:nvSpPr>
-          <p:cNvPr id="10" name="Text 7"/>
-          <p:cNvSpPr txBox="1"/>
-          <p:nvPr/>
-        </p:nvSpPr>
-        <p:spPr>
-          <a:xfrm>
-            <a:off x="5440680" y="4636008"/>
-            <a:ext cx="3017520" cy="201168"/>
-          </a:xfrm>
-          <a:prstGeom prst="rect">
-            <a:avLst/>
-          </a:prstGeom>
-          <a:noFill/>
-          <a:ln/>
-        </p:spPr>
-        <p:txBody>
-          <a:bodyPr wrap="square" lIns="0" tIns="0" rIns="0" bIns="0" rtlCol="0" anchor="ctr"/>
-          <a:lstStyle/>
           <a:p>
             <a:pPr indent="0" marL="0">
               <a:buNone/>
@@ -10530,7 +10232,7 @@
               </a:rPr>
               <a:t>Photo: [source / credit]</a:t>
             </a:r>
-            <a:endParaRPr lang="en-US" sz="800" dirty="0"/>
+            <a:endParaRPr lang="en-US" sz="1400" dirty="0"/>
           </a:p>
         </p:txBody>
       </p:sp>
@@ -10613,8 +10315,8 @@
         </p:nvSpPr>
         <p:spPr>
           <a:xfrm>
-            <a:off x="457200" y="548640"/>
-            <a:ext cx="8229600" cy="594360"/>
+            <a:off x="457200" y="566928"/>
+            <a:ext cx="8229600" cy="548640"/>
           </a:xfrm>
           <a:prstGeom prst="rect">
             <a:avLst/>
@@ -10630,7 +10332,7 @@
               <a:buNone/>
             </a:pPr>
             <a:r>
-              <a:rPr lang="en-US" sz="2800" dirty="0">
+              <a:rPr lang="en-US" sz="2400" dirty="0">
                 <a:solidFill>
                   <a:srgbClr val="DBE3EA"/>
                 </a:solidFill>
@@ -10640,7 +10342,7 @@
               </a:rPr>
               <a:t>Data mein persistent, predictable patterns</a:t>
             </a:r>
-            <a:endParaRPr lang="en-US" sz="2800" dirty="0"/>
+            <a:endParaRPr lang="en-US" sz="2400" dirty="0"/>
           </a:p>
         </p:txBody>
       </p:sp>
@@ -10917,17 +10619,17 @@
         </p:nvSpPr>
         <p:spPr>
           <a:xfrm>
-            <a:off x="4526280" y="3794760"/>
-            <a:ext cx="4114800" cy="256032"/>
-          </a:xfrm>
-          <a:prstGeom prst="rect">
-            <a:avLst/>
-          </a:prstGeom>
-          <a:noFill/>
-          <a:ln/>
-        </p:spPr>
-        <p:txBody>
-          <a:bodyPr wrap="square" lIns="0" tIns="0" rIns="0" bIns="0" rtlCol="0" anchor="ctr"/>
+            <a:off x="4526280" y="3986212"/>
+            <a:ext cx="4160520" cy="274320"/>
+          </a:xfrm>
+          <a:prstGeom prst="rect">
+            <a:avLst/>
+          </a:prstGeom>
+          <a:noFill/>
+          <a:ln/>
+        </p:spPr>
+        <p:txBody>
+          <a:bodyPr wrap="square" lIns="0" tIns="0" rIns="0" bIns="0" rtlCol="0" anchor="t"/>
           <a:lstStyle/>
           <a:p>
             <a:pPr indent="0" marL="0">
@@ -11027,8 +10729,8 @@
         </p:nvSpPr>
         <p:spPr>
           <a:xfrm>
-            <a:off x="457200" y="548640"/>
-            <a:ext cx="8229600" cy="594360"/>
+            <a:off x="457200" y="566928"/>
+            <a:ext cx="8229600" cy="548640"/>
           </a:xfrm>
           <a:prstGeom prst="rect">
             <a:avLst/>
@@ -11044,7 +10746,7 @@
               <a:buNone/>
             </a:pPr>
             <a:r>
-              <a:rPr lang="en-US" sz="2800" dirty="0">
+              <a:rPr lang="en-US" sz="2400" dirty="0">
                 <a:solidFill>
                   <a:srgbClr val="DBE3EA"/>
                 </a:solidFill>
@@ -11054,7 +10756,7 @@
               </a:rPr>
               <a:t>Stories nahi — statistical pattern recognition</a:t>
             </a:r>
-            <a:endParaRPr lang="en-US" sz="2800" dirty="0"/>
+            <a:endParaRPr lang="en-US" sz="2400" dirty="0"/>
           </a:p>
         </p:txBody>
       </p:sp>
@@ -11402,8 +11104,8 @@
         </p:nvSpPr>
         <p:spPr>
           <a:xfrm>
-            <a:off x="457200" y="548640"/>
-            <a:ext cx="8229600" cy="594360"/>
+            <a:off x="457200" y="566928"/>
+            <a:ext cx="8229600" cy="548640"/>
           </a:xfrm>
           <a:prstGeom prst="rect">
             <a:avLst/>
@@ -11419,7 +11121,7 @@
               <a:buNone/>
             </a:pPr>
             <a:r>
-              <a:rPr lang="en-US" sz="2800" dirty="0">
+              <a:rPr lang="en-US" sz="2400" dirty="0">
                 <a:solidFill>
                   <a:srgbClr val="DBE3EA"/>
                 </a:solidFill>
@@ -11429,7 +11131,7 @@
               </a:rPr>
               <a:t>Performance sirf models ki wajah se nahi thi</a:t>
             </a:r>
-            <a:endParaRPr lang="en-US" sz="2800" dirty="0"/>
+            <a:endParaRPr lang="en-US" sz="2400" dirty="0"/>
           </a:p>
         </p:txBody>
       </p:sp>
@@ -12122,8 +11824,8 @@
         </p:nvSpPr>
         <p:spPr>
           <a:xfrm>
-            <a:off x="457200" y="548640"/>
-            <a:ext cx="8229600" cy="594360"/>
+            <a:off x="457200" y="566928"/>
+            <a:ext cx="8229600" cy="548640"/>
           </a:xfrm>
           <a:prstGeom prst="rect">
             <a:avLst/>
@@ -12139,7 +11841,7 @@
               <a:buNone/>
             </a:pPr>
             <a:r>
-              <a:rPr lang="en-US" sz="2800" dirty="0">
+              <a:rPr lang="en-US" sz="2400" dirty="0">
                 <a:solidFill>
                   <a:srgbClr val="DBE3EA"/>
                 </a:solidFill>
@@ -12149,7 +11851,7 @@
               </a:rPr>
               <a:t>Edge ke 4 pillars</a:t>
             </a:r>
-            <a:endParaRPr lang="en-US" sz="2800" dirty="0"/>
+            <a:endParaRPr lang="en-US" sz="2400" dirty="0"/>
           </a:p>
         </p:txBody>
       </p:sp>
@@ -12225,7 +11927,7 @@
         <p:spPr>
           <a:xfrm>
             <a:off x="2606040" y="1280160"/>
-            <a:ext cx="1920240" cy="548640"/>
+            <a:ext cx="1965960" cy="1600200"/>
           </a:xfrm>
           <a:prstGeom prst="rect">
             <a:avLst/>
@@ -12238,6 +11940,9 @@
           <a:lstStyle/>
           <a:p>
             <a:pPr indent="0" marL="0">
+              <a:spcAft>
+                <a:spcPts val="300"/>
+              </a:spcAft>
               <a:buNone/>
             </a:pPr>
             <a:r>
@@ -12253,28 +11958,6 @@
             </a:r>
             <a:endParaRPr lang="en-US" sz="1200" dirty="0"/>
           </a:p>
-        </p:txBody>
-      </p:sp>
-      <p:sp>
-        <p:nvSpPr>
-          <p:cNvPr id="7" name="Text 4"/>
-          <p:cNvSpPr txBox="1"/>
-          <p:nvPr/>
-        </p:nvSpPr>
-        <p:spPr>
-          <a:xfrm>
-            <a:off x="2606040" y="1828800"/>
-            <a:ext cx="1920240" cy="822960"/>
-          </a:xfrm>
-          <a:prstGeom prst="rect">
-            <a:avLst/>
-          </a:prstGeom>
-          <a:noFill/>
-          <a:ln/>
-        </p:spPr>
-        <p:txBody>
-          <a:bodyPr wrap="square" lIns="0" tIns="0" rIns="0" bIns="0" rtlCol="0" anchor="t"/>
-          <a:lstStyle/>
           <a:p>
             <a:pPr indent="0" marL="0">
               <a:buNone/>
@@ -12290,13 +11973,13 @@
               </a:rPr>
               <a:t>Significant, repeat hone wale, costs ke baad bhi useful signals</a:t>
             </a:r>
-            <a:endParaRPr lang="en-US" sz="1100" dirty="0"/>
+            <a:endParaRPr lang="en-US" sz="1200" dirty="0"/>
           </a:p>
         </p:txBody>
       </p:sp>
       <p:pic>
         <p:nvPicPr>
-          <p:cNvPr id="8" name="Image 1" descr="Video frame, scene S10">    </p:cNvPr>
+          <p:cNvPr id="7" name="Image 1" descr="Video frame, scene S10">    </p:cNvPr>
           <p:cNvPicPr>
             <a:picLocks noChangeAspect="1"/>
           </p:cNvPicPr>
@@ -12320,14 +12003,14 @@
       </p:pic>
       <p:sp>
         <p:nvSpPr>
-          <p:cNvPr id="9" name="Text 5"/>
+          <p:cNvPr id="8" name="Text 4"/>
           <p:cNvSpPr txBox="1"/>
           <p:nvPr/>
         </p:nvSpPr>
         <p:spPr>
           <a:xfrm>
             <a:off x="6812280" y="1280160"/>
-            <a:ext cx="1920240" cy="548640"/>
+            <a:ext cx="1965960" cy="1600200"/>
           </a:xfrm>
           <a:prstGeom prst="rect">
             <a:avLst/>
@@ -12340,6 +12023,9 @@
           <a:lstStyle/>
           <a:p>
             <a:pPr indent="0" marL="0">
+              <a:spcAft>
+                <a:spcPts val="300"/>
+              </a:spcAft>
               <a:buNone/>
             </a:pPr>
             <a:r>
@@ -12355,28 +12041,6 @@
             </a:r>
             <a:endParaRPr lang="en-US" sz="1200" dirty="0"/>
           </a:p>
-        </p:txBody>
-      </p:sp>
-      <p:sp>
-        <p:nvSpPr>
-          <p:cNvPr id="10" name="Text 6"/>
-          <p:cNvSpPr txBox="1"/>
-          <p:nvPr/>
-        </p:nvSpPr>
-        <p:spPr>
-          <a:xfrm>
-            <a:off x="6812280" y="1828800"/>
-            <a:ext cx="1920240" cy="822960"/>
-          </a:xfrm>
-          <a:prstGeom prst="rect">
-            <a:avLst/>
-          </a:prstGeom>
-          <a:noFill/>
-          <a:ln/>
-        </p:spPr>
-        <p:txBody>
-          <a:bodyPr wrap="square" lIns="0" tIns="0" rIns="0" bIns="0" rtlCol="0" anchor="t"/>
-          <a:lstStyle/>
           <a:p>
             <a:pPr indent="0" marL="0">
               <a:buNone/>
@@ -12392,13 +12056,13 @@
               </a:rPr>
               <a:t>Physics, signal processing; Hidden Markov Models (reportedly)</a:t>
             </a:r>
-            <a:endParaRPr lang="en-US" sz="1100" dirty="0"/>
+            <a:endParaRPr lang="en-US" sz="1200" dirty="0"/>
           </a:p>
         </p:txBody>
       </p:sp>
       <p:pic>
         <p:nvPicPr>
-          <p:cNvPr id="11" name="Image 2" descr="Video frame, scene S11">    </p:cNvPr>
+          <p:cNvPr id="9" name="Image 2" descr="Video frame, scene S11">    </p:cNvPr>
           <p:cNvPicPr>
             <a:picLocks noChangeAspect="1"/>
           </p:cNvPicPr>
@@ -12422,14 +12086,14 @@
       </p:pic>
       <p:sp>
         <p:nvSpPr>
-          <p:cNvPr id="12" name="Text 7"/>
+          <p:cNvPr id="10" name="Text 5"/>
           <p:cNvSpPr txBox="1"/>
           <p:nvPr/>
         </p:nvSpPr>
         <p:spPr>
           <a:xfrm>
             <a:off x="2606040" y="3108960"/>
-            <a:ext cx="1920240" cy="548640"/>
+            <a:ext cx="1965960" cy="1600200"/>
           </a:xfrm>
           <a:prstGeom prst="rect">
             <a:avLst/>
@@ -12442,6 +12106,9 @@
           <a:lstStyle/>
           <a:p>
             <a:pPr indent="0" marL="0">
+              <a:spcAft>
+                <a:spcPts val="300"/>
+              </a:spcAft>
               <a:buNone/>
             </a:pPr>
             <a:r>
@@ -12457,28 +12124,6 @@
             </a:r>
             <a:endParaRPr lang="en-US" sz="1200" dirty="0"/>
           </a:p>
-        </p:txBody>
-      </p:sp>
-      <p:sp>
-        <p:nvSpPr>
-          <p:cNvPr id="13" name="Text 8"/>
-          <p:cNvSpPr txBox="1"/>
-          <p:nvPr/>
-        </p:nvSpPr>
-        <p:spPr>
-          <a:xfrm>
-            <a:off x="2606040" y="3657600"/>
-            <a:ext cx="1920240" cy="822960"/>
-          </a:xfrm>
-          <a:prstGeom prst="rect">
-            <a:avLst/>
-          </a:prstGeom>
-          <a:noFill/>
-          <a:ln/>
-        </p:spPr>
-        <p:txBody>
-          <a:bodyPr wrap="square" lIns="0" tIns="0" rIns="0" bIns="0" rtlCol="0" anchor="t"/>
-          <a:lstStyle/>
           <a:p>
             <a:pPr indent="0" marL="0">
               <a:buNone/>
@@ -12494,13 +12139,13 @@
               </a:rPr>
               <a:t>Medallion ki capacity intentionally limited rakhi gayi</a:t>
             </a:r>
-            <a:endParaRPr lang="en-US" sz="1100" dirty="0"/>
+            <a:endParaRPr lang="en-US" sz="1200" dirty="0"/>
           </a:p>
         </p:txBody>
       </p:sp>
       <p:pic>
         <p:nvPicPr>
-          <p:cNvPr id="14" name="Image 3" descr="Video frame, scene S12">    </p:cNvPr>
+          <p:cNvPr id="11" name="Image 3" descr="Video frame, scene S12">    </p:cNvPr>
           <p:cNvPicPr>
             <a:picLocks noChangeAspect="1"/>
           </p:cNvPicPr>
@@ -12524,14 +12169,14 @@
       </p:pic>
       <p:sp>
         <p:nvSpPr>
-          <p:cNvPr id="15" name="Text 9"/>
+          <p:cNvPr id="12" name="Text 6"/>
           <p:cNvSpPr txBox="1"/>
           <p:nvPr/>
         </p:nvSpPr>
         <p:spPr>
           <a:xfrm>
             <a:off x="6812280" y="3108960"/>
-            <a:ext cx="1920240" cy="548640"/>
+            <a:ext cx="1965960" cy="1600200"/>
           </a:xfrm>
           <a:prstGeom prst="rect">
             <a:avLst/>
@@ -12544,6 +12189,9 @@
           <a:lstStyle/>
           <a:p>
             <a:pPr indent="0" marL="0">
+              <a:spcAft>
+                <a:spcPts val="300"/>
+              </a:spcAft>
               <a:buNone/>
             </a:pPr>
             <a:r>
@@ -12559,28 +12207,6 @@
             </a:r>
             <a:endParaRPr lang="en-US" sz="1200" dirty="0"/>
           </a:p>
-        </p:txBody>
-      </p:sp>
-      <p:sp>
-        <p:nvSpPr>
-          <p:cNvPr id="16" name="Text 10"/>
-          <p:cNvSpPr txBox="1"/>
-          <p:nvPr/>
-        </p:nvSpPr>
-        <p:spPr>
-          <a:xfrm>
-            <a:off x="6812280" y="3657600"/>
-            <a:ext cx="1920240" cy="822960"/>
-          </a:xfrm>
-          <a:prstGeom prst="rect">
-            <a:avLst/>
-          </a:prstGeom>
-          <a:noFill/>
-          <a:ln/>
-        </p:spPr>
-        <p:txBody>
-          <a:bodyPr wrap="square" lIns="0" tIns="0" rIns="0" bIns="0" rtlCol="0" anchor="t"/>
-          <a:lstStyle/>
           <a:p>
             <a:pPr indent="0" marL="0">
               <a:buNone/>
@@ -12596,7 +12222,7 @@
               </a:rPr>
               <a:t>Evidence ho to trade; kaam band kare to remove</a:t>
             </a:r>
-            <a:endParaRPr lang="en-US" sz="1100" dirty="0"/>
+            <a:endParaRPr lang="en-US" sz="1200" dirty="0"/>
           </a:p>
         </p:txBody>
       </p:sp>
@@ -12679,8 +12305,8 @@
         </p:nvSpPr>
         <p:spPr>
           <a:xfrm>
-            <a:off x="457200" y="548640"/>
-            <a:ext cx="8229600" cy="594360"/>
+            <a:off x="457200" y="566928"/>
+            <a:ext cx="8229600" cy="548640"/>
           </a:xfrm>
           <a:prstGeom prst="rect">
             <a:avLst/>
@@ -12696,7 +12322,7 @@
               <a:buNone/>
             </a:pPr>
             <a:r>
-              <a:rPr lang="en-US" sz="2800" dirty="0">
+              <a:rPr lang="en-US" sz="2400" dirty="0">
                 <a:solidFill>
                   <a:srgbClr val="DBE3EA"/>
                 </a:solidFill>
@@ -12706,7 +12332,7 @@
               </a:rPr>
               <a:t>Process kabhi rukta nahi tha</a:t>
             </a:r>
-            <a:endParaRPr lang="en-US" sz="2800" dirty="0"/>
+            <a:endParaRPr lang="en-US" sz="2400" dirty="0"/>
           </a:p>
         </p:txBody>
       </p:sp>

</xml_diff>